<commit_message>
Auto-build: 2026-10-09 09:18 UTC
</commit_message>
<xml_diff>
--- a/reports/2026-09.pptx
+++ b/reports/2026-09.pptx
@@ -241,16 +241,16 @@
                     <c:v>Tanzania</c:v>
                   </c:pt>
                   <c:pt idx="1">
+                    <c:v>Uganda</c:v>
+                  </c:pt>
+                  <c:pt idx="2">
                     <c:v>Kenya</c:v>
                   </c:pt>
-                  <c:pt idx="2">
+                  <c:pt idx="3">
                     <c:v>Nigeria</c:v>
                   </c:pt>
-                  <c:pt idx="3">
+                  <c:pt idx="4">
                     <c:v>Sierra Leone</c:v>
-                  </c:pt>
-                  <c:pt idx="4">
-                    <c:v>Uganda</c:v>
                   </c:pt>
                 </c:lvl>
               </c:multiLvlStrCache>
@@ -266,16 +266,16 @@
                   <c:v>88</c:v>
                 </c:pt>
                 <c:pt idx="1">
+                  <c:v>75</c:v>
+                </c:pt>
+                <c:pt idx="2">
                   <c:v>67</c:v>
                 </c:pt>
-                <c:pt idx="2">
+                <c:pt idx="3">
                   <c:v>50</c:v>
                 </c:pt>
-                <c:pt idx="3">
+                <c:pt idx="4">
                   <c:v>45</c:v>
-                </c:pt>
-                <c:pt idx="4">
-                  <c:v>0</c:v>
                 </c:pt>
               </c:numCache>
             </c:numRef>
@@ -563,7 +563,7 @@
                 <c:formatCode>General</c:formatCode>
                 <c:ptCount val="5"/>
                 <c:pt idx="0">
-                  <c:v>0</c:v>
+                  <c:v>10</c:v>
                 </c:pt>
                 <c:pt idx="1">
                   <c:v>34</c:v>
@@ -844,13 +844,13 @@
                     <c:v>Nigeria</c:v>
                   </c:pt>
                   <c:pt idx="2">
+                    <c:v>Uganda</c:v>
+                  </c:pt>
+                  <c:pt idx="3">
                     <c:v>Sierra Leone</c:v>
                   </c:pt>
-                  <c:pt idx="3">
+                  <c:pt idx="4">
                     <c:v>Tanzania</c:v>
-                  </c:pt>
-                  <c:pt idx="4">
-                    <c:v>Uganda</c:v>
                   </c:pt>
                 </c:lvl>
               </c:multiLvlStrCache>
@@ -869,10 +869,10 @@
                   <c:v>0.900424</c:v>
                 </c:pt>
                 <c:pt idx="2">
-                  <c:v>0.729746</c:v>
+                  <c:v>0.855277</c:v>
                 </c:pt>
                 <c:pt idx="3">
-                  <c:v>0</c:v>
+                  <c:v>0.729746</c:v>
                 </c:pt>
                 <c:pt idx="4">
                   <c:v>0</c:v>
@@ -1147,10 +1147,10 @@
                     <c:v>Sierra Leone</c:v>
                   </c:pt>
                   <c:pt idx="3">
-                    <c:v>Nigeria</c:v>
+                    <c:v>Uganda</c:v>
                   </c:pt>
                   <c:pt idx="4">
-                    <c:v>Uganda</c:v>
+                    <c:v>Nigeria</c:v>
                   </c:pt>
                 </c:lvl>
               </c:multiLvlStrCache>
@@ -1172,10 +1172,10 @@
                   <c:v>623203.2044</c:v>
                 </c:pt>
                 <c:pt idx="3">
-                  <c:v>161574.6269</c:v>
+                  <c:v>518626.8932</c:v>
                 </c:pt>
                 <c:pt idx="4">
-                  <c:v>0</c:v>
+                  <c:v>161574.6269</c:v>
                 </c:pt>
               </c:numCache>
             </c:numRef>
@@ -1447,10 +1447,10 @@
                     <c:v>Sierra Leone</c:v>
                   </c:pt>
                   <c:pt idx="3">
-                    <c:v>Nigeria</c:v>
+                    <c:v>Uganda</c:v>
                   </c:pt>
                   <c:pt idx="4">
-                    <c:v>Uganda</c:v>
+                    <c:v>Nigeria</c:v>
                   </c:pt>
                 </c:lvl>
               </c:multiLvlStrCache>
@@ -1472,10 +1472,10 @@
                   <c:v>509.56926</c:v>
                 </c:pt>
                 <c:pt idx="3">
-                  <c:v>204.784064</c:v>
+                  <c:v>220.317287</c:v>
                 </c:pt>
                 <c:pt idx="4">
-                  <c:v>0</c:v>
+                  <c:v>204.784064</c:v>
                 </c:pt>
               </c:numCache>
             </c:numRef>
@@ -1747,10 +1747,10 @@
                     <c:v>Sierra Leone</c:v>
                   </c:pt>
                   <c:pt idx="3">
-                    <c:v>Nigeria</c:v>
+                    <c:v>Uganda</c:v>
                   </c:pt>
                   <c:pt idx="4">
-                    <c:v>Uganda</c:v>
+                    <c:v>Nigeria</c:v>
                   </c:pt>
                 </c:lvl>
               </c:multiLvlStrCache>
@@ -1772,10 +1772,10 @@
                   <c:v>23</c:v>
                 </c:pt>
                 <c:pt idx="3">
-                  <c:v>34</c:v>
+                  <c:v>62</c:v>
                 </c:pt>
                 <c:pt idx="4">
-                  <c:v>0</c:v>
+                  <c:v>34</c:v>
                 </c:pt>
               </c:numCache>
             </c:numRef>
@@ -2038,19 +2038,19 @@
                 <c:ptCount val="5"/>
                 <c:lvl>
                   <c:pt idx="0">
+                    <c:v>Uganda</c:v>
+                  </c:pt>
+                  <c:pt idx="1">
                     <c:v>Nigeria</c:v>
                   </c:pt>
-                  <c:pt idx="1">
+                  <c:pt idx="2">
                     <c:v>Tanzania</c:v>
                   </c:pt>
-                  <c:pt idx="2">
+                  <c:pt idx="3">
                     <c:v>Kenya</c:v>
                   </c:pt>
-                  <c:pt idx="3">
+                  <c:pt idx="4">
                     <c:v>Sierra Leone</c:v>
-                  </c:pt>
-                  <c:pt idx="4">
-                    <c:v>Uganda</c:v>
                   </c:pt>
                 </c:lvl>
               </c:multiLvlStrCache>
@@ -2066,16 +2066,16 @@
                   <c:v>2</c:v>
                 </c:pt>
                 <c:pt idx="1">
+                  <c:v>2</c:v>
+                </c:pt>
+                <c:pt idx="2">
                   <c:v>3</c:v>
                 </c:pt>
-                <c:pt idx="2">
+                <c:pt idx="3">
                   <c:v>4</c:v>
                 </c:pt>
-                <c:pt idx="3">
+                <c:pt idx="4">
                   <c:v>5</c:v>
-                </c:pt>
-                <c:pt idx="4">
-                  <c:v>0</c:v>
                 </c:pt>
               </c:numCache>
             </c:numRef>
@@ -2347,10 +2347,10 @@
                     <c:v>Sierra Leone</c:v>
                   </c:pt>
                   <c:pt idx="3">
-                    <c:v>Nigeria</c:v>
+                    <c:v>Uganda</c:v>
                   </c:pt>
                   <c:pt idx="4">
-                    <c:v>Uganda</c:v>
+                    <c:v>Nigeria</c:v>
                   </c:pt>
                 </c:lvl>
               </c:multiLvlStrCache>
@@ -2372,10 +2372,10 @@
                   <c:v>1320429.609</c:v>
                 </c:pt>
                 <c:pt idx="3">
-                  <c:v>343133.7595</c:v>
+                  <c:v>1298823.678</c:v>
                 </c:pt>
                 <c:pt idx="4">
-                  <c:v>0</c:v>
+                  <c:v>343133.7595</c:v>
                 </c:pt>
               </c:numCache>
             </c:numRef>
@@ -2638,13 +2638,13 @@
                 <c:ptCount val="5"/>
                 <c:lvl>
                   <c:pt idx="0">
-                    <c:v>Uganda</c:v>
+                    <c:v>Nigeria</c:v>
                   </c:pt>
                   <c:pt idx="1">
-                    <c:v>Nigeria</c:v>
+                    <c:v>Sierra Leone</c:v>
                   </c:pt>
                   <c:pt idx="2">
-                    <c:v>Sierra Leone</c:v>
+                    <c:v>Uganda</c:v>
                   </c:pt>
                   <c:pt idx="3">
                     <c:v>Kenya</c:v>
@@ -2663,13 +2663,13 @@
                 <c:formatCode>General</c:formatCode>
                 <c:ptCount val="5"/>
                 <c:pt idx="0">
-                  <c:v>0</c:v>
+                  <c:v>696</c:v>
                 </c:pt>
                 <c:pt idx="1">
-                  <c:v>696</c:v>
+                  <c:v>888</c:v>
                 </c:pt>
                 <c:pt idx="2">
-                  <c:v>888</c:v>
+                  <c:v>1184</c:v>
                 </c:pt>
                 <c:pt idx="3">
                   <c:v>1388</c:v>
@@ -2938,13 +2938,13 @@
                 <c:ptCount val="5"/>
                 <c:lvl>
                   <c:pt idx="0">
-                    <c:v>Uganda</c:v>
+                    <c:v>Sierra Leone</c:v>
                   </c:pt>
                   <c:pt idx="1">
-                    <c:v>Sierra Leone</c:v>
+                    <c:v>Nigeria</c:v>
                   </c:pt>
                   <c:pt idx="2">
-                    <c:v>Nigeria</c:v>
+                    <c:v>Uganda</c:v>
                   </c:pt>
                   <c:pt idx="3">
                     <c:v>Kenya</c:v>
@@ -2963,13 +2963,13 @@
                 <c:formatCode>General</c:formatCode>
                 <c:ptCount val="5"/>
                 <c:pt idx="0">
-                  <c:v>0</c:v>
+                  <c:v>111</c:v>
                 </c:pt>
                 <c:pt idx="1">
-                  <c:v>111</c:v>
+                  <c:v>121</c:v>
                 </c:pt>
                 <c:pt idx="2">
-                  <c:v>121</c:v>
+                  <c:v>128</c:v>
                 </c:pt>
                 <c:pt idx="3">
                   <c:v>223</c:v>
@@ -7616,7 +7616,7 @@
                           <a:ea typeface="Calibri" pitchFamily="34" charset="-122"/>
                           <a:cs typeface="Calibri" pitchFamily="34" charset="-120"/>
                         </a:rPr>
-                        <a:t>—</a:t>
+                        <a:t>$191,478</a:t>
                       </a:r>
                       <a:endParaRPr lang="en-US" sz="1200" dirty="0">
                         <a:latin typeface="Calibri" charset="0"/>
@@ -7684,7 +7684,7 @@
                           <a:ea typeface="Calibri" pitchFamily="34" charset="-122"/>
                           <a:cs typeface="Calibri" pitchFamily="34" charset="-120"/>
                         </a:rPr>
-                        <a:t>—</a:t>
+                        <a:t>$-55,163</a:t>
                       </a:r>
                       <a:endParaRPr lang="en-US" sz="1200" dirty="0">
                         <a:latin typeface="Calibri" charset="0"/>
@@ -7752,7 +7752,7 @@
                           <a:ea typeface="Calibri" pitchFamily="34" charset="-122"/>
                           <a:cs typeface="Calibri" pitchFamily="34" charset="-120"/>
                         </a:rPr>
-                        <a:t>—</a:t>
+                        <a:t>$-146,661</a:t>
                       </a:r>
                       <a:endParaRPr lang="en-US" sz="1200" dirty="0">
                         <a:latin typeface="Calibri" charset="0"/>
@@ -7814,13 +7814,13 @@
                       <a:r>
                         <a:rPr lang="en-US" sz="1200" dirty="0">
                           <a:solidFill>
-                            <a:srgbClr val="2D2A26"/>
+                            <a:srgbClr val="C0392B"/>
                           </a:solidFill>
                           <a:latin typeface="Calibri" pitchFamily="34" charset="0"/>
                           <a:ea typeface="Calibri" pitchFamily="34" charset="-122"/>
                           <a:cs typeface="Calibri" pitchFamily="34" charset="-120"/>
                         </a:rPr>
-                        <a:t>—</a:t>
+                        <a:t>$-10,346</a:t>
                       </a:r>
                       <a:endParaRPr lang="en-US" sz="1200" dirty="0">
                         <a:latin typeface="Calibri" charset="0"/>
@@ -7882,13 +7882,13 @@
                       <a:r>
                         <a:rPr lang="en-US" sz="1200" dirty="0">
                           <a:solidFill>
-                            <a:srgbClr val="2D2A26"/>
+                            <a:srgbClr val="C0392B"/>
                           </a:solidFill>
                           <a:latin typeface="Calibri" pitchFamily="34" charset="0"/>
                           <a:ea typeface="Calibri" pitchFamily="34" charset="-122"/>
                           <a:cs typeface="Calibri" pitchFamily="34" charset="-120"/>
                         </a:rPr>
-                        <a:t>N/M</a:t>
+                        <a:t>-5.4%</a:t>
                       </a:r>
                       <a:endParaRPr lang="en-US" sz="1200" dirty="0">
                         <a:latin typeface="Calibri" charset="0"/>
@@ -7950,13 +7950,13 @@
                       <a:r>
                         <a:rPr lang="en-US" sz="1200" dirty="0">
                           <a:solidFill>
-                            <a:srgbClr val="2D2A26"/>
+                            <a:srgbClr val="C0392B"/>
                           </a:solidFill>
                           <a:latin typeface="Calibri" pitchFamily="34" charset="0"/>
                           <a:ea typeface="Calibri" pitchFamily="34" charset="-122"/>
                           <a:cs typeface="Calibri" pitchFamily="34" charset="-120"/>
                         </a:rPr>
-                        <a:t>—</a:t>
+                        <a:t>$-20,922</a:t>
                       </a:r>
                       <a:endParaRPr lang="en-US" sz="1200" dirty="0">
                         <a:latin typeface="Calibri" charset="0"/>
@@ -8572,7 +8572,7 @@
                           <a:ea typeface="Calibri" pitchFamily="34" charset="-122"/>
                           <a:cs typeface="Calibri" pitchFamily="34" charset="-120"/>
                         </a:rPr>
-                        <a:t>$1,848,903</a:t>
+                        <a:t>$2,040,381</a:t>
                       </a:r>
                       <a:endParaRPr lang="en-US" sz="1200" dirty="0">
                         <a:latin typeface="Calibri" charset="0"/>
@@ -8640,7 +8640,7 @@
                           <a:ea typeface="Calibri" pitchFamily="34" charset="-122"/>
                           <a:cs typeface="Calibri" pitchFamily="34" charset="-120"/>
                         </a:rPr>
-                        <a:t>$-299,464</a:t>
+                        <a:t>$-354,627</a:t>
                       </a:r>
                       <a:endParaRPr lang="en-US" sz="1200" dirty="0">
                         <a:latin typeface="Calibri" charset="0"/>
@@ -8708,7 +8708,7 @@
                           <a:ea typeface="Calibri" pitchFamily="34" charset="-122"/>
                           <a:cs typeface="Calibri" pitchFamily="34" charset="-120"/>
                         </a:rPr>
-                        <a:t>$-1,240,308</a:t>
+                        <a:t>$-1,386,969</a:t>
                       </a:r>
                       <a:endParaRPr lang="en-US" sz="1200" dirty="0">
                         <a:latin typeface="Calibri" charset="0"/>
@@ -8776,7 +8776,7 @@
                           <a:ea typeface="Calibri" pitchFamily="34" charset="-122"/>
                           <a:cs typeface="Calibri" pitchFamily="34" charset="-120"/>
                         </a:rPr>
-                        <a:t>$309,131</a:t>
+                        <a:t>$298,784</a:t>
                       </a:r>
                       <a:endParaRPr lang="en-US" sz="1200" dirty="0">
                         <a:latin typeface="Calibri" charset="0"/>
@@ -8844,7 +8844,7 @@
                           <a:ea typeface="Calibri" pitchFamily="34" charset="-122"/>
                           <a:cs typeface="Calibri" pitchFamily="34" charset="-120"/>
                         </a:rPr>
-                        <a:t>16.7%</a:t>
+                        <a:t>14.6%</a:t>
                       </a:r>
                       <a:endParaRPr lang="en-US" sz="1200" dirty="0">
                         <a:latin typeface="Calibri" charset="0"/>
@@ -8912,7 +8912,7 @@
                           <a:ea typeface="Calibri" pitchFamily="34" charset="-122"/>
                           <a:cs typeface="Calibri" pitchFamily="34" charset="-120"/>
                         </a:rPr>
-                        <a:t>$159,590</a:t>
+                        <a:t>$138,668</a:t>
                       </a:r>
                       <a:endParaRPr lang="en-US" sz="1200" dirty="0">
                         <a:latin typeface="Calibri" charset="0"/>
@@ -9097,7 +9097,7 @@
                 <a:ea typeface="Century Gothic" pitchFamily="34" charset="-122"/>
                 <a:cs typeface="Century Gothic" pitchFamily="34" charset="-120"/>
               </a:rPr>
-              <a:t>$1,848,903</a:t>
+              <a:t>$2,040,381</a:t>
             </a:r>
             <a:endParaRPr lang="en-US" sz="2600" dirty="0"/>
           </a:p>
@@ -9232,7 +9232,7 @@
                 <a:ea typeface="Century Gothic" pitchFamily="34" charset="-122"/>
                 <a:cs typeface="Century Gothic" pitchFamily="34" charset="-120"/>
               </a:rPr>
-              <a:t>$309,131</a:t>
+              <a:t>$298,784</a:t>
             </a:r>
             <a:endParaRPr lang="en-US" sz="2600" dirty="0"/>
           </a:p>
@@ -9367,7 +9367,7 @@
                 <a:ea typeface="Century Gothic" pitchFamily="34" charset="-122"/>
                 <a:cs typeface="Century Gothic" pitchFamily="34" charset="-120"/>
               </a:rPr>
-              <a:t>16.7%</a:t>
+              <a:t>14.6%</a:t>
             </a:r>
             <a:endParaRPr lang="en-US" sz="2600" dirty="0"/>
           </a:p>
@@ -9850,45 +9850,6 @@
             <a:r>
               <a:rPr lang="en-US" sz="1200" b="1" dirty="0">
                 <a:solidFill>
-                  <a:srgbClr val="718096"/>
-                </a:solidFill>
-                <a:latin typeface="Calibri" pitchFamily="34" charset="0"/>
-                <a:ea typeface="Calibri" pitchFamily="34" charset="-122"/>
-                <a:cs typeface="Calibri" pitchFamily="34" charset="-120"/>
-              </a:rPr>
-              <a:t>—</a:t>
-            </a:r>
-            <a:endParaRPr lang="en-US" sz="1200" dirty="0"/>
-          </a:p>
-        </p:txBody>
-      </p:sp>
-      <p:sp>
-        <p:nvSpPr>
-          <p:cNvPr id="16" name="Text 13"/>
-          <p:cNvSpPr/>
-          <p:nvPr/>
-        </p:nvSpPr>
-        <p:spPr>
-          <a:xfrm>
-            <a:off x="2514600" y="5943600"/>
-            <a:ext cx="2377440" cy="347472"/>
-          </a:xfrm>
-          <a:prstGeom prst="rect">
-            <a:avLst/>
-          </a:prstGeom>
-          <a:noFill/>
-          <a:ln/>
-        </p:spPr>
-        <p:txBody>
-          <a:bodyPr wrap="square" rtlCol="0" anchor="ctr"/>
-          <a:lstStyle/>
-          <a:p>
-            <a:pPr algn="ctr" indent="0" marL="0">
-              <a:buNone/>
-            </a:pPr>
-            <a:r>
-              <a:rPr lang="en-US" sz="1200" b="1" dirty="0">
-                <a:solidFill>
                   <a:srgbClr val="C0392B"/>
                 </a:solidFill>
                 <a:latin typeface="Calibri" pitchFamily="34" charset="0"/>
@@ -9903,13 +9864,13 @@
       </p:sp>
       <p:sp>
         <p:nvSpPr>
-          <p:cNvPr id="17" name="Text 14"/>
-          <p:cNvSpPr/>
-          <p:nvPr/>
-        </p:nvSpPr>
-        <p:spPr>
-          <a:xfrm>
-            <a:off x="4892040" y="5943600"/>
+          <p:cNvPr id="16" name="Text 13"/>
+          <p:cNvSpPr/>
+          <p:nvPr/>
+        </p:nvSpPr>
+        <p:spPr>
+          <a:xfrm>
+            <a:off x="2514600" y="5943600"/>
             <a:ext cx="2377440" cy="347472"/>
           </a:xfrm>
           <a:prstGeom prst="rect">
@@ -9935,6 +9896,45 @@
                 <a:cs typeface="Calibri" pitchFamily="34" charset="-120"/>
               </a:rPr>
               <a:t>+3.6%</a:t>
+            </a:r>
+            <a:endParaRPr lang="en-US" sz="1200" dirty="0"/>
+          </a:p>
+        </p:txBody>
+      </p:sp>
+      <p:sp>
+        <p:nvSpPr>
+          <p:cNvPr id="17" name="Text 14"/>
+          <p:cNvSpPr/>
+          <p:nvPr/>
+        </p:nvSpPr>
+        <p:spPr>
+          <a:xfrm>
+            <a:off x="4892040" y="5943600"/>
+            <a:ext cx="2377440" cy="347472"/>
+          </a:xfrm>
+          <a:prstGeom prst="rect">
+            <a:avLst/>
+          </a:prstGeom>
+          <a:noFill/>
+          <a:ln/>
+        </p:spPr>
+        <p:txBody>
+          <a:bodyPr wrap="square" rtlCol="0" anchor="ctr"/>
+          <a:lstStyle/>
+          <a:p>
+            <a:pPr algn="ctr" indent="0" marL="0">
+              <a:buNone/>
+            </a:pPr>
+            <a:r>
+              <a:rPr lang="en-US" sz="1200" b="1" dirty="0">
+                <a:solidFill>
+                  <a:srgbClr val="1A7A6E"/>
+                </a:solidFill>
+                <a:latin typeface="Calibri" pitchFamily="34" charset="0"/>
+                <a:ea typeface="Calibri" pitchFamily="34" charset="-122"/>
+                <a:cs typeface="Calibri" pitchFamily="34" charset="-120"/>
+              </a:rPr>
+              <a:t>-3.4%</a:t>
             </a:r>
             <a:endParaRPr lang="en-US" sz="1200" dirty="0"/>
           </a:p>
@@ -10456,45 +10456,6 @@
             <a:r>
               <a:rPr lang="en-US" sz="1200" b="1" dirty="0">
                 <a:solidFill>
-                  <a:srgbClr val="718096"/>
-                </a:solidFill>
-                <a:latin typeface="Calibri" pitchFamily="34" charset="0"/>
-                <a:ea typeface="Calibri" pitchFamily="34" charset="-122"/>
-                <a:cs typeface="Calibri" pitchFamily="34" charset="-120"/>
-              </a:rPr>
-              <a:t>—</a:t>
-            </a:r>
-            <a:endParaRPr lang="en-US" sz="1200" dirty="0"/>
-          </a:p>
-        </p:txBody>
-      </p:sp>
-      <p:sp>
-        <p:nvSpPr>
-          <p:cNvPr id="16" name="Text 13"/>
-          <p:cNvSpPr/>
-          <p:nvPr/>
-        </p:nvSpPr>
-        <p:spPr>
-          <a:xfrm>
-            <a:off x="2514600" y="5486400"/>
-            <a:ext cx="2377440" cy="347472"/>
-          </a:xfrm>
-          <a:prstGeom prst="rect">
-            <a:avLst/>
-          </a:prstGeom>
-          <a:noFill/>
-          <a:ln/>
-        </p:spPr>
-        <p:txBody>
-          <a:bodyPr wrap="square" rtlCol="0" anchor="ctr"/>
-          <a:lstStyle/>
-          <a:p>
-            <a:pPr algn="ctr" indent="0" marL="0">
-              <a:buNone/>
-            </a:pPr>
-            <a:r>
-              <a:rPr lang="en-US" sz="1200" b="1" dirty="0">
-                <a:solidFill>
                   <a:srgbClr val="1A7A6E"/>
                 </a:solidFill>
                 <a:latin typeface="Calibri" pitchFamily="34" charset="0"/>
@@ -10509,13 +10470,13 @@
       </p:sp>
       <p:sp>
         <p:nvSpPr>
-          <p:cNvPr id="17" name="Text 14"/>
-          <p:cNvSpPr/>
-          <p:nvPr/>
-        </p:nvSpPr>
-        <p:spPr>
-          <a:xfrm>
-            <a:off x="4892040" y="5486400"/>
+          <p:cNvPr id="16" name="Text 13"/>
+          <p:cNvSpPr/>
+          <p:nvPr/>
+        </p:nvSpPr>
+        <p:spPr>
+          <a:xfrm>
+            <a:off x="2514600" y="5486400"/>
             <a:ext cx="2377440" cy="347472"/>
           </a:xfrm>
           <a:prstGeom prst="rect">
@@ -10548,6 +10509,45 @@
       </p:sp>
       <p:sp>
         <p:nvSpPr>
+          <p:cNvPr id="17" name="Text 14"/>
+          <p:cNvSpPr/>
+          <p:nvPr/>
+        </p:nvSpPr>
+        <p:spPr>
+          <a:xfrm>
+            <a:off x="4892040" y="5486400"/>
+            <a:ext cx="2377440" cy="347472"/>
+          </a:xfrm>
+          <a:prstGeom prst="rect">
+            <a:avLst/>
+          </a:prstGeom>
+          <a:noFill/>
+          <a:ln/>
+        </p:spPr>
+        <p:txBody>
+          <a:bodyPr wrap="square" rtlCol="0" anchor="ctr"/>
+          <a:lstStyle/>
+          <a:p>
+            <a:pPr algn="ctr" indent="0" marL="0">
+              <a:buNone/>
+            </a:pPr>
+            <a:r>
+              <a:rPr lang="en-US" sz="1200" b="1" dirty="0">
+                <a:solidFill>
+                  <a:srgbClr val="C0392B"/>
+                </a:solidFill>
+                <a:latin typeface="Calibri" pitchFamily="34" charset="0"/>
+                <a:ea typeface="Calibri" pitchFamily="34" charset="-122"/>
+                <a:cs typeface="Calibri" pitchFamily="34" charset="-120"/>
+              </a:rPr>
+              <a:t>+3.2%</a:t>
+            </a:r>
+            <a:endParaRPr lang="en-US" sz="1200" dirty="0"/>
+          </a:p>
+        </p:txBody>
+      </p:sp>
+      <p:sp>
+        <p:nvSpPr>
           <p:cNvPr id="18" name="Text 15"/>
           <p:cNvSpPr/>
           <p:nvPr/>
@@ -10740,45 +10740,6 @@
             <a:r>
               <a:rPr lang="en-US" sz="1200" b="1" dirty="0">
                 <a:solidFill>
-                  <a:srgbClr val="718096"/>
-                </a:solidFill>
-                <a:latin typeface="Calibri" pitchFamily="34" charset="0"/>
-                <a:ea typeface="Calibri" pitchFamily="34" charset="-122"/>
-                <a:cs typeface="Calibri" pitchFamily="34" charset="-120"/>
-              </a:rPr>
-              <a:t>—</a:t>
-            </a:r>
-            <a:endParaRPr lang="en-US" sz="1200" dirty="0"/>
-          </a:p>
-        </p:txBody>
-      </p:sp>
-      <p:sp>
-        <p:nvSpPr>
-          <p:cNvPr id="24" name="Text 21"/>
-          <p:cNvSpPr/>
-          <p:nvPr/>
-        </p:nvSpPr>
-        <p:spPr>
-          <a:xfrm>
-            <a:off x="2514600" y="6199632"/>
-            <a:ext cx="2377440" cy="347472"/>
-          </a:xfrm>
-          <a:prstGeom prst="rect">
-            <a:avLst/>
-          </a:prstGeom>
-          <a:noFill/>
-          <a:ln/>
-        </p:spPr>
-        <p:txBody>
-          <a:bodyPr wrap="square" rtlCol="0" anchor="ctr"/>
-          <a:lstStyle/>
-          <a:p>
-            <a:pPr algn="ctr" indent="0" marL="0">
-              <a:buNone/>
-            </a:pPr>
-            <a:r>
-              <a:rPr lang="en-US" sz="1200" b="1" dirty="0">
-                <a:solidFill>
                   <a:srgbClr val="1A7A6E"/>
                 </a:solidFill>
                 <a:latin typeface="Calibri" pitchFamily="34" charset="0"/>
@@ -10793,13 +10754,13 @@
       </p:sp>
       <p:sp>
         <p:nvSpPr>
-          <p:cNvPr id="25" name="Text 22"/>
-          <p:cNvSpPr/>
-          <p:nvPr/>
-        </p:nvSpPr>
-        <p:spPr>
-          <a:xfrm>
-            <a:off x="4892040" y="6199632"/>
+          <p:cNvPr id="24" name="Text 21"/>
+          <p:cNvSpPr/>
+          <p:nvPr/>
+        </p:nvSpPr>
+        <p:spPr>
+          <a:xfrm>
+            <a:off x="2514600" y="6199632"/>
             <a:ext cx="2377440" cy="347472"/>
           </a:xfrm>
           <a:prstGeom prst="rect">
@@ -10825,6 +10786,45 @@
                 <a:cs typeface="Calibri" pitchFamily="34" charset="-120"/>
               </a:rPr>
               <a:t>-10.5%</a:t>
+            </a:r>
+            <a:endParaRPr lang="en-US" sz="1200" dirty="0"/>
+          </a:p>
+        </p:txBody>
+      </p:sp>
+      <p:sp>
+        <p:nvSpPr>
+          <p:cNvPr id="25" name="Text 22"/>
+          <p:cNvSpPr/>
+          <p:nvPr/>
+        </p:nvSpPr>
+        <p:spPr>
+          <a:xfrm>
+            <a:off x="4892040" y="6199632"/>
+            <a:ext cx="2377440" cy="347472"/>
+          </a:xfrm>
+          <a:prstGeom prst="rect">
+            <a:avLst/>
+          </a:prstGeom>
+          <a:noFill/>
+          <a:ln/>
+        </p:spPr>
+        <p:txBody>
+          <a:bodyPr wrap="square" rtlCol="0" anchor="ctr"/>
+          <a:lstStyle/>
+          <a:p>
+            <a:pPr algn="ctr" indent="0" marL="0">
+              <a:buNone/>
+            </a:pPr>
+            <a:r>
+              <a:rPr lang="en-US" sz="1200" b="1" dirty="0">
+                <a:solidFill>
+                  <a:srgbClr val="1A7A6E"/>
+                </a:solidFill>
+                <a:latin typeface="Calibri" pitchFamily="34" charset="0"/>
+                <a:ea typeface="Calibri" pitchFamily="34" charset="-122"/>
+                <a:cs typeface="Calibri" pitchFamily="34" charset="-120"/>
+              </a:rPr>
+              <a:t>+1.6%</a:t>
             </a:r>
             <a:endParaRPr lang="en-US" sz="1200" dirty="0"/>
           </a:p>
@@ -11346,13 +11346,13 @@
             <a:r>
               <a:rPr lang="en-US" sz="1200" b="1" dirty="0">
                 <a:solidFill>
-                  <a:srgbClr val="718096"/>
+                  <a:srgbClr val="C0392B"/>
                 </a:solidFill>
                 <a:latin typeface="Calibri" pitchFamily="34" charset="0"/>
                 <a:ea typeface="Calibri" pitchFamily="34" charset="-122"/>
                 <a:cs typeface="Calibri" pitchFamily="34" charset="-120"/>
               </a:rPr>
-              <a:t>—</a:t>
+              <a:t>+11.1%</a:t>
             </a:r>
             <a:endParaRPr lang="en-US" sz="1200" dirty="0"/>
           </a:p>
@@ -11630,13 +11630,13 @@
             <a:r>
               <a:rPr lang="en-US" sz="1200" b="1" dirty="0">
                 <a:solidFill>
-                  <a:srgbClr val="718096"/>
+                  <a:srgbClr val="1A7A6E"/>
                 </a:solidFill>
                 <a:latin typeface="Calibri" pitchFamily="34" charset="0"/>
                 <a:ea typeface="Calibri" pitchFamily="34" charset="-122"/>
                 <a:cs typeface="Calibri" pitchFamily="34" charset="-120"/>
               </a:rPr>
-              <a:t>—</a:t>
+              <a:t>+1.6%</a:t>
             </a:r>
             <a:endParaRPr lang="en-US" sz="1200" dirty="0"/>
           </a:p>
@@ -12275,6 +12275,45 @@
             <a:r>
               <a:rPr lang="en-US" sz="1200" b="1" dirty="0">
                 <a:solidFill>
+                  <a:srgbClr val="1A7A6E"/>
+                </a:solidFill>
+                <a:latin typeface="Calibri" pitchFamily="34" charset="0"/>
+                <a:ea typeface="Calibri" pitchFamily="34" charset="-122"/>
+                <a:cs typeface="Calibri" pitchFamily="34" charset="-120"/>
+              </a:rPr>
+              <a:t>+1.4%</a:t>
+            </a:r>
+            <a:endParaRPr lang="en-US" sz="1200" dirty="0"/>
+          </a:p>
+        </p:txBody>
+      </p:sp>
+      <p:sp>
+        <p:nvSpPr>
+          <p:cNvPr id="17" name="Text 14"/>
+          <p:cNvSpPr/>
+          <p:nvPr/>
+        </p:nvSpPr>
+        <p:spPr>
+          <a:xfrm>
+            <a:off x="3172968" y="5925312"/>
+            <a:ext cx="1517904" cy="347472"/>
+          </a:xfrm>
+          <a:prstGeom prst="rect">
+            <a:avLst/>
+          </a:prstGeom>
+          <a:noFill/>
+          <a:ln/>
+        </p:spPr>
+        <p:txBody>
+          <a:bodyPr wrap="square" rtlCol="0" anchor="ctr"/>
+          <a:lstStyle/>
+          <a:p>
+            <a:pPr algn="ctr" indent="0" marL="0">
+              <a:buNone/>
+            </a:pPr>
+            <a:r>
+              <a:rPr lang="en-US" sz="1200" b="1" dirty="0">
+                <a:solidFill>
                   <a:srgbClr val="C0392B"/>
                 </a:solidFill>
                 <a:latin typeface="Calibri" pitchFamily="34" charset="0"/>
@@ -12289,13 +12328,13 @@
       </p:sp>
       <p:sp>
         <p:nvSpPr>
-          <p:cNvPr id="17" name="Text 14"/>
-          <p:cNvSpPr/>
-          <p:nvPr/>
-        </p:nvSpPr>
-        <p:spPr>
-          <a:xfrm>
-            <a:off x="3172968" y="5925312"/>
+          <p:cNvPr id="18" name="Text 15"/>
+          <p:cNvSpPr/>
+          <p:nvPr/>
+        </p:nvSpPr>
+        <p:spPr>
+          <a:xfrm>
+            <a:off x="4690872" y="5925312"/>
             <a:ext cx="1517904" cy="347472"/>
           </a:xfrm>
           <a:prstGeom prst="rect">
@@ -12328,13 +12367,13 @@
       </p:sp>
       <p:sp>
         <p:nvSpPr>
-          <p:cNvPr id="18" name="Text 15"/>
-          <p:cNvSpPr/>
-          <p:nvPr/>
-        </p:nvSpPr>
-        <p:spPr>
-          <a:xfrm>
-            <a:off x="4690872" y="5925312"/>
+          <p:cNvPr id="19" name="Text 16"/>
+          <p:cNvSpPr/>
+          <p:nvPr/>
+        </p:nvSpPr>
+        <p:spPr>
+          <a:xfrm>
+            <a:off x="6208776" y="5925312"/>
             <a:ext cx="1517904" cy="347472"/>
           </a:xfrm>
           <a:prstGeom prst="rect">
@@ -12360,45 +12399,6 @@
                 <a:cs typeface="Calibri" pitchFamily="34" charset="-120"/>
               </a:rPr>
               <a:t>+0.0%</a:t>
-            </a:r>
-            <a:endParaRPr lang="en-US" sz="1200" dirty="0"/>
-          </a:p>
-        </p:txBody>
-      </p:sp>
-      <p:sp>
-        <p:nvSpPr>
-          <p:cNvPr id="19" name="Text 16"/>
-          <p:cNvSpPr/>
-          <p:nvPr/>
-        </p:nvSpPr>
-        <p:spPr>
-          <a:xfrm>
-            <a:off x="6208776" y="5925312"/>
-            <a:ext cx="1517904" cy="347472"/>
-          </a:xfrm>
-          <a:prstGeom prst="rect">
-            <a:avLst/>
-          </a:prstGeom>
-          <a:noFill/>
-          <a:ln/>
-        </p:spPr>
-        <p:txBody>
-          <a:bodyPr wrap="square" rtlCol="0" anchor="ctr"/>
-          <a:lstStyle/>
-          <a:p>
-            <a:pPr algn="ctr" indent="0" marL="0">
-              <a:buNone/>
-            </a:pPr>
-            <a:r>
-              <a:rPr lang="en-US" sz="1200" b="1" dirty="0">
-                <a:solidFill>
-                  <a:srgbClr val="718096"/>
-                </a:solidFill>
-                <a:latin typeface="Calibri" pitchFamily="34" charset="0"/>
-                <a:ea typeface="Calibri" pitchFamily="34" charset="-122"/>
-                <a:cs typeface="Calibri" pitchFamily="34" charset="-120"/>
-              </a:rPr>
-              <a:t>—</a:t>
             </a:r>
             <a:endParaRPr lang="en-US" sz="1200" dirty="0"/>
           </a:p>
@@ -12494,7 +12494,7 @@
                 <a:ea typeface="Century Gothic" pitchFamily="34" charset="-122"/>
                 <a:cs typeface="Century Gothic" pitchFamily="34" charset="-120"/>
               </a:rPr>
-              <a:t>22,247</a:t>
+              <a:t>25,004</a:t>
             </a:r>
             <a:endParaRPr lang="en-US" sz="2600" dirty="0"/>
           </a:p>
@@ -12764,7 +12764,7 @@
                 <a:ea typeface="Century Gothic" pitchFamily="34" charset="-122"/>
                 <a:cs typeface="Century Gothic" pitchFamily="34" charset="-120"/>
               </a:rPr>
-              <a:t>+12.3%</a:t>
+              <a:t>+10.6%</a:t>
             </a:r>
             <a:endParaRPr lang="en-US" sz="2600" dirty="0"/>
           </a:p>
@@ -12931,7 +12931,7 @@
                 <a:ea typeface="Calibri" pitchFamily="34" charset="-122"/>
                 <a:cs typeface="Calibri" pitchFamily="34" charset="-120"/>
               </a:rPr>
-              <a:t>Group total: 22,247 applications (+12.1% vs prior month).</a:t>
+              <a:t>Group total: 25,004 applications (+10.7% vs prior month).</a:t>
             </a:r>
             <a:endParaRPr lang="en-US" sz="1200" dirty="0"/>
           </a:p>
@@ -13509,13 +13509,13 @@
             <a:r>
               <a:rPr lang="en-US" sz="1200" b="1" dirty="0">
                 <a:solidFill>
-                  <a:srgbClr val="718096"/>
+                  <a:srgbClr val="C0392B"/>
                 </a:solidFill>
                 <a:latin typeface="Calibri" pitchFamily="34" charset="0"/>
                 <a:ea typeface="Calibri" pitchFamily="34" charset="-122"/>
                 <a:cs typeface="Calibri" pitchFamily="34" charset="-120"/>
               </a:rPr>
-              <a:t>—</a:t>
+              <a:t>↓</a:t>
             </a:r>
             <a:endParaRPr lang="en-US" sz="1200" dirty="0"/>
           </a:p>
@@ -13650,7 +13650,7 @@
                 <a:ea typeface="Century Gothic" pitchFamily="34" charset="-122"/>
                 <a:cs typeface="Century Gothic" pitchFamily="34" charset="-120"/>
               </a:rPr>
-              <a:t>8,731</a:t>
+              <a:t>11,089</a:t>
             </a:r>
             <a:endParaRPr lang="en-US" sz="2600" dirty="0"/>
           </a:p>
@@ -13785,7 +13785,7 @@
                 <a:ea typeface="Century Gothic" pitchFamily="34" charset="-122"/>
                 <a:cs typeface="Century Gothic" pitchFamily="34" charset="-120"/>
               </a:rPr>
-              <a:t>39.2%</a:t>
+              <a:t>44.3%</a:t>
             </a:r>
             <a:endParaRPr lang="en-US" sz="2600" dirty="0"/>
           </a:p>
@@ -14087,7 +14087,7 @@
                 <a:ea typeface="Calibri" pitchFamily="34" charset="-122"/>
                 <a:cs typeface="Calibri" pitchFamily="34" charset="-120"/>
               </a:rPr>
-              <a:t>Group total approvals: 8,731.</a:t>
+              <a:t>Group total approvals: 11,089.</a:t>
             </a:r>
             <a:endParaRPr lang="en-US" sz="1200" dirty="0"/>
           </a:p>
@@ -14665,6 +14665,45 @@
             <a:r>
               <a:rPr lang="en-US" sz="1200" b="1" dirty="0">
                 <a:solidFill>
+                  <a:srgbClr val="C0392B"/>
+                </a:solidFill>
+                <a:latin typeface="Calibri" pitchFamily="34" charset="0"/>
+                <a:ea typeface="Calibri" pitchFamily="34" charset="-122"/>
+                <a:cs typeface="Calibri" pitchFamily="34" charset="-120"/>
+              </a:rPr>
+              <a:t>-1.3%</a:t>
+            </a:r>
+            <a:endParaRPr lang="en-US" sz="1200" dirty="0"/>
+          </a:p>
+        </p:txBody>
+      </p:sp>
+      <p:sp>
+        <p:nvSpPr>
+          <p:cNvPr id="19" name="Text 16"/>
+          <p:cNvSpPr/>
+          <p:nvPr/>
+        </p:nvSpPr>
+        <p:spPr>
+          <a:xfrm>
+            <a:off x="6208776" y="5925312"/>
+            <a:ext cx="1517904" cy="347472"/>
+          </a:xfrm>
+          <a:prstGeom prst="rect">
+            <a:avLst/>
+          </a:prstGeom>
+          <a:noFill/>
+          <a:ln/>
+        </p:spPr>
+        <p:txBody>
+          <a:bodyPr wrap="square" rtlCol="0" anchor="ctr"/>
+          <a:lstStyle/>
+          <a:p>
+            <a:pPr algn="ctr" indent="0" marL="0">
+              <a:buNone/>
+            </a:pPr>
+            <a:r>
+              <a:rPr lang="en-US" sz="1200" b="1" dirty="0">
+                <a:solidFill>
                   <a:srgbClr val="1A7A6E"/>
                 </a:solidFill>
                 <a:latin typeface="Calibri" pitchFamily="34" charset="0"/>
@@ -14672,45 +14711,6 @@
                 <a:cs typeface="Calibri" pitchFamily="34" charset="-120"/>
               </a:rPr>
               <a:t>+12.0%</a:t>
-            </a:r>
-            <a:endParaRPr lang="en-US" sz="1200" dirty="0"/>
-          </a:p>
-        </p:txBody>
-      </p:sp>
-      <p:sp>
-        <p:nvSpPr>
-          <p:cNvPr id="19" name="Text 16"/>
-          <p:cNvSpPr/>
-          <p:nvPr/>
-        </p:nvSpPr>
-        <p:spPr>
-          <a:xfrm>
-            <a:off x="6208776" y="5925312"/>
-            <a:ext cx="1517904" cy="347472"/>
-          </a:xfrm>
-          <a:prstGeom prst="rect">
-            <a:avLst/>
-          </a:prstGeom>
-          <a:noFill/>
-          <a:ln/>
-        </p:spPr>
-        <p:txBody>
-          <a:bodyPr wrap="square" rtlCol="0" anchor="ctr"/>
-          <a:lstStyle/>
-          <a:p>
-            <a:pPr algn="ctr" indent="0" marL="0">
-              <a:buNone/>
-            </a:pPr>
-            <a:r>
-              <a:rPr lang="en-US" sz="1200" b="1" dirty="0">
-                <a:solidFill>
-                  <a:srgbClr val="718096"/>
-                </a:solidFill>
-                <a:latin typeface="Calibri" pitchFamily="34" charset="0"/>
-                <a:ea typeface="Calibri" pitchFamily="34" charset="-122"/>
-                <a:cs typeface="Calibri" pitchFamily="34" charset="-120"/>
-              </a:rPr>
-              <a:t>—</a:t>
             </a:r>
             <a:endParaRPr lang="en-US" sz="1200" dirty="0"/>
           </a:p>
@@ -14806,7 +14806,7 @@
                 <a:ea typeface="Century Gothic" pitchFamily="34" charset="-122"/>
                 <a:cs typeface="Century Gothic" pitchFamily="34" charset="-120"/>
               </a:rPr>
-              <a:t>$5,266,124</a:t>
+              <a:t>$5,784,751</a:t>
             </a:r>
             <a:endParaRPr lang="en-US" sz="2600" dirty="0"/>
           </a:p>
@@ -14941,7 +14941,7 @@
                 <a:ea typeface="Century Gothic" pitchFamily="34" charset="-122"/>
                 <a:cs typeface="Century Gothic" pitchFamily="34" charset="-120"/>
               </a:rPr>
-              <a:t>+11.4%</a:t>
+              <a:t>+10.1%</a:t>
             </a:r>
             <a:endParaRPr lang="en-US" sz="2600" dirty="0"/>
           </a:p>
@@ -15076,7 +15076,7 @@
                 <a:ea typeface="Century Gothic" pitchFamily="34" charset="-122"/>
                 <a:cs typeface="Century Gothic" pitchFamily="34" charset="-120"/>
               </a:rPr>
-              <a:t>68</a:t>
+              <a:t>67</a:t>
             </a:r>
             <a:endParaRPr lang="en-US" sz="2600" dirty="0"/>
           </a:p>
@@ -15577,6 +15577,109 @@
                 <a:ea typeface="Calibri" pitchFamily="34" charset="-122"/>
                 <a:cs typeface="Calibri" pitchFamily="34" charset="-120"/>
               </a:rPr>
+              <a:t>Uganda</a:t>
+            </a:r>
+            <a:endParaRPr lang="en-US" sz="1100" dirty="0"/>
+          </a:p>
+        </p:txBody>
+      </p:sp>
+      <p:sp>
+        <p:nvSpPr>
+          <p:cNvPr id="46" name="Text 43"/>
+          <p:cNvSpPr/>
+          <p:nvPr/>
+        </p:nvSpPr>
+        <p:spPr>
+          <a:xfrm>
+            <a:off x="7955280" y="4855464"/>
+            <a:ext cx="1234440" cy="292608"/>
+          </a:xfrm>
+          <a:prstGeom prst="rect">
+            <a:avLst/>
+          </a:prstGeom>
+          <a:noFill/>
+          <a:ln/>
+        </p:spPr>
+        <p:txBody>
+          <a:bodyPr wrap="square" rtlCol="0" anchor="ctr"/>
+          <a:lstStyle/>
+          <a:p>
+            <a:pPr algn="ctr" indent="0" marL="0">
+              <a:buNone/>
+            </a:pPr>
+            <a:r>
+              <a:rPr lang="en-US" sz="1100" b="1" dirty="0">
+                <a:solidFill>
+                  <a:srgbClr val="5D300F"/>
+                </a:solidFill>
+                <a:latin typeface="Century Gothic" pitchFamily="34" charset="0"/>
+                <a:ea typeface="Century Gothic" pitchFamily="34" charset="-122"/>
+                <a:cs typeface="Century Gothic" pitchFamily="34" charset="-120"/>
+              </a:rPr>
+              <a:t>37</a:t>
+            </a:r>
+            <a:endParaRPr lang="en-US" sz="1100" dirty="0"/>
+          </a:p>
+        </p:txBody>
+      </p:sp>
+      <p:sp>
+        <p:nvSpPr>
+          <p:cNvPr id="47" name="Shape 44"/>
+          <p:cNvSpPr/>
+          <p:nvPr/>
+        </p:nvSpPr>
+        <p:spPr>
+          <a:xfrm>
+            <a:off x="9308592" y="4617720"/>
+            <a:ext cx="1234440" cy="530352"/>
+          </a:xfrm>
+          <a:prstGeom prst="rect">
+            <a:avLst/>
+          </a:prstGeom>
+          <a:solidFill>
+            <a:srgbClr val="FFF9D9"/>
+          </a:solidFill>
+          <a:ln w="12700">
+            <a:solidFill>
+              <a:srgbClr val="D6CFC4"/>
+            </a:solidFill>
+            <a:prstDash val="solid"/>
+          </a:ln>
+        </p:spPr>
+      </p:sp>
+      <p:sp>
+        <p:nvSpPr>
+          <p:cNvPr id="48" name="Text 45"/>
+          <p:cNvSpPr/>
+          <p:nvPr/>
+        </p:nvSpPr>
+        <p:spPr>
+          <a:xfrm>
+            <a:off x="9308592" y="4617720"/>
+            <a:ext cx="1234440" cy="237744"/>
+          </a:xfrm>
+          <a:prstGeom prst="rect">
+            <a:avLst/>
+          </a:prstGeom>
+          <a:noFill/>
+          <a:ln/>
+        </p:spPr>
+        <p:txBody>
+          <a:bodyPr wrap="square" rtlCol="0" anchor="b"/>
+          <a:lstStyle/>
+          <a:p>
+            <a:pPr algn="ctr" indent="0" marL="0">
+              <a:buNone/>
+            </a:pPr>
+            <a:r>
+              <a:rPr lang="en-US" sz="1100" dirty="0">
+                <a:solidFill>
+                  <a:srgbClr val="718096"/>
+                </a:solidFill>
+                <a:latin typeface="Calibri" pitchFamily="34" charset="0"/>
+                <a:ea typeface="Calibri" pitchFamily="34" charset="-122"/>
+                <a:cs typeface="Calibri" pitchFamily="34" charset="-120"/>
+              </a:rPr>
               <a:t>Nigeria</a:t>
             </a:r>
             <a:endParaRPr lang="en-US" sz="1100" dirty="0"/>
@@ -15585,13 +15688,13 @@
       </p:sp>
       <p:sp>
         <p:nvSpPr>
-          <p:cNvPr id="46" name="Text 43"/>
-          <p:cNvSpPr/>
-          <p:nvPr/>
-        </p:nvSpPr>
-        <p:spPr>
-          <a:xfrm>
-            <a:off x="7955280" y="4855464"/>
+          <p:cNvPr id="49" name="Text 46"/>
+          <p:cNvSpPr/>
+          <p:nvPr/>
+        </p:nvSpPr>
+        <p:spPr>
+          <a:xfrm>
+            <a:off x="9308592" y="4855464"/>
             <a:ext cx="1234440" cy="292608"/>
           </a:xfrm>
           <a:prstGeom prst="rect">
@@ -15624,109 +15727,6 @@
       </p:sp>
       <p:sp>
         <p:nvSpPr>
-          <p:cNvPr id="47" name="Shape 44"/>
-          <p:cNvSpPr/>
-          <p:nvPr/>
-        </p:nvSpPr>
-        <p:spPr>
-          <a:xfrm>
-            <a:off x="9308592" y="4617720"/>
-            <a:ext cx="1234440" cy="530352"/>
-          </a:xfrm>
-          <a:prstGeom prst="rect">
-            <a:avLst/>
-          </a:prstGeom>
-          <a:solidFill>
-            <a:srgbClr val="FFF9D9"/>
-          </a:solidFill>
-          <a:ln w="12700">
-            <a:solidFill>
-              <a:srgbClr val="D6CFC4"/>
-            </a:solidFill>
-            <a:prstDash val="solid"/>
-          </a:ln>
-        </p:spPr>
-      </p:sp>
-      <p:sp>
-        <p:nvSpPr>
-          <p:cNvPr id="48" name="Text 45"/>
-          <p:cNvSpPr/>
-          <p:nvPr/>
-        </p:nvSpPr>
-        <p:spPr>
-          <a:xfrm>
-            <a:off x="9308592" y="4617720"/>
-            <a:ext cx="1234440" cy="237744"/>
-          </a:xfrm>
-          <a:prstGeom prst="rect">
-            <a:avLst/>
-          </a:prstGeom>
-          <a:noFill/>
-          <a:ln/>
-        </p:spPr>
-        <p:txBody>
-          <a:bodyPr wrap="square" rtlCol="0" anchor="b"/>
-          <a:lstStyle/>
-          <a:p>
-            <a:pPr algn="ctr" indent="0" marL="0">
-              <a:buNone/>
-            </a:pPr>
-            <a:r>
-              <a:rPr lang="en-US" sz="1100" dirty="0">
-                <a:solidFill>
-                  <a:srgbClr val="718096"/>
-                </a:solidFill>
-                <a:latin typeface="Calibri" pitchFamily="34" charset="0"/>
-                <a:ea typeface="Calibri" pitchFamily="34" charset="-122"/>
-                <a:cs typeface="Calibri" pitchFamily="34" charset="-120"/>
-              </a:rPr>
-              <a:t>Uganda</a:t>
-            </a:r>
-            <a:endParaRPr lang="en-US" sz="1100" dirty="0"/>
-          </a:p>
-        </p:txBody>
-      </p:sp>
-      <p:sp>
-        <p:nvSpPr>
-          <p:cNvPr id="49" name="Text 46"/>
-          <p:cNvSpPr/>
-          <p:nvPr/>
-        </p:nvSpPr>
-        <p:spPr>
-          <a:xfrm>
-            <a:off x="9308592" y="4855464"/>
-            <a:ext cx="1234440" cy="292608"/>
-          </a:xfrm>
-          <a:prstGeom prst="rect">
-            <a:avLst/>
-          </a:prstGeom>
-          <a:noFill/>
-          <a:ln/>
-        </p:spPr>
-        <p:txBody>
-          <a:bodyPr wrap="square" rtlCol="0" anchor="ctr"/>
-          <a:lstStyle/>
-          <a:p>
-            <a:pPr algn="ctr" indent="0" marL="0">
-              <a:buNone/>
-            </a:pPr>
-            <a:r>
-              <a:rPr lang="en-US" sz="1100" b="1" dirty="0">
-                <a:solidFill>
-                  <a:srgbClr val="5D300F"/>
-                </a:solidFill>
-                <a:latin typeface="Century Gothic" pitchFamily="34" charset="0"/>
-                <a:ea typeface="Century Gothic" pitchFamily="34" charset="-122"/>
-                <a:cs typeface="Century Gothic" pitchFamily="34" charset="-120"/>
-              </a:rPr>
-              <a:t>—</a:t>
-            </a:r>
-            <a:endParaRPr lang="en-US" sz="1100" dirty="0"/>
-          </a:p>
-        </p:txBody>
-      </p:sp>
-      <p:sp>
-        <p:nvSpPr>
           <p:cNvPr id="50" name="Shape 47"/>
           <p:cNvSpPr/>
           <p:nvPr/>
@@ -15847,7 +15847,7 @@
                 <a:ea typeface="Calibri" pitchFamily="34" charset="-122"/>
                 <a:cs typeface="Calibri" pitchFamily="34" charset="-120"/>
               </a:rPr>
-              <a:t>Total disbursed: $5,266,124 (+11.4% vs prior month).</a:t>
+              <a:t>Total disbursed: $5,784,751 (+10.1% vs prior month).</a:t>
             </a:r>
             <a:endParaRPr lang="en-US" sz="1200" dirty="0"/>
           </a:p>
@@ -16536,7 +16536,7 @@
                 <a:ea typeface="Calibri" pitchFamily="34" charset="-122"/>
                 <a:cs typeface="Calibri" pitchFamily="34" charset="-120"/>
               </a:rPr>
-              <a:t>+2.1%</a:t>
+              <a:t>+2.4%</a:t>
             </a:r>
             <a:endParaRPr lang="en-US" sz="1200" dirty="0"/>
           </a:p>
@@ -16569,13 +16569,13 @@
             <a:r>
               <a:rPr lang="en-US" sz="1200" b="1" dirty="0">
                 <a:solidFill>
-                  <a:srgbClr val="718096"/>
+                  <a:srgbClr val="1A7A6E"/>
                 </a:solidFill>
                 <a:latin typeface="Calibri" pitchFamily="34" charset="0"/>
                 <a:ea typeface="Calibri" pitchFamily="34" charset="-122"/>
                 <a:cs typeface="Calibri" pitchFamily="34" charset="-120"/>
               </a:rPr>
-              <a:t>—</a:t>
+              <a:t>+2.1%</a:t>
             </a:r>
             <a:endParaRPr lang="en-US" sz="1200" dirty="0"/>
           </a:p>
@@ -16814,6 +16814,45 @@
             <a:r>
               <a:rPr lang="en-US" sz="1200" b="1" dirty="0">
                 <a:solidFill>
+                  <a:srgbClr val="1A7A6E"/>
+                </a:solidFill>
+                <a:latin typeface="Calibri" pitchFamily="34" charset="0"/>
+                <a:ea typeface="Calibri" pitchFamily="34" charset="-122"/>
+                <a:cs typeface="Calibri" pitchFamily="34" charset="-120"/>
+              </a:rPr>
+              <a:t>+1.6%</a:t>
+            </a:r>
+            <a:endParaRPr lang="en-US" sz="1200" dirty="0"/>
+          </a:p>
+        </p:txBody>
+      </p:sp>
+      <p:sp>
+        <p:nvSpPr>
+          <p:cNvPr id="31" name="Text 27"/>
+          <p:cNvSpPr/>
+          <p:nvPr/>
+        </p:nvSpPr>
+        <p:spPr>
+          <a:xfrm>
+            <a:off x="10817352" y="5925312"/>
+            <a:ext cx="1161288" cy="347472"/>
+          </a:xfrm>
+          <a:prstGeom prst="rect">
+            <a:avLst/>
+          </a:prstGeom>
+          <a:noFill/>
+          <a:ln/>
+        </p:spPr>
+        <p:txBody>
+          <a:bodyPr wrap="square" rtlCol="0" anchor="ctr"/>
+          <a:lstStyle/>
+          <a:p>
+            <a:pPr algn="ctr" indent="0" marL="0">
+              <a:buNone/>
+            </a:pPr>
+            <a:r>
+              <a:rPr lang="en-US" sz="1200" b="1" dirty="0">
+                <a:solidFill>
                   <a:srgbClr val="C0392B"/>
                 </a:solidFill>
                 <a:latin typeface="Calibri" pitchFamily="34" charset="0"/>
@@ -16821,45 +16860,6 @@
                 <a:cs typeface="Calibri" pitchFamily="34" charset="-120"/>
               </a:rPr>
               <a:t>-10.5%</a:t>
-            </a:r>
-            <a:endParaRPr lang="en-US" sz="1200" dirty="0"/>
-          </a:p>
-        </p:txBody>
-      </p:sp>
-      <p:sp>
-        <p:nvSpPr>
-          <p:cNvPr id="31" name="Text 27"/>
-          <p:cNvSpPr/>
-          <p:nvPr/>
-        </p:nvSpPr>
-        <p:spPr>
-          <a:xfrm>
-            <a:off x="10817352" y="5925312"/>
-            <a:ext cx="1161288" cy="347472"/>
-          </a:xfrm>
-          <a:prstGeom prst="rect">
-            <a:avLst/>
-          </a:prstGeom>
-          <a:noFill/>
-          <a:ln/>
-        </p:spPr>
-        <p:txBody>
-          <a:bodyPr wrap="square" rtlCol="0" anchor="ctr"/>
-          <a:lstStyle/>
-          <a:p>
-            <a:pPr algn="ctr" indent="0" marL="0">
-              <a:buNone/>
-            </a:pPr>
-            <a:r>
-              <a:rPr lang="en-US" sz="1200" b="1" dirty="0">
-                <a:solidFill>
-                  <a:srgbClr val="718096"/>
-                </a:solidFill>
-                <a:latin typeface="Calibri" pitchFamily="34" charset="0"/>
-                <a:ea typeface="Calibri" pitchFamily="34" charset="-122"/>
-                <a:cs typeface="Calibri" pitchFamily="34" charset="-120"/>
-              </a:rPr>
-              <a:t>—</a:t>
             </a:r>
             <a:endParaRPr lang="en-US" sz="1200" dirty="0"/>
           </a:p>
@@ -17348,6 +17348,45 @@
                 <a:ea typeface="Calibri" pitchFamily="34" charset="-122"/>
                 <a:cs typeface="Calibri" pitchFamily="34" charset="-120"/>
               </a:rPr>
+              <a:t>↓</a:t>
+            </a:r>
+            <a:endParaRPr lang="en-US" sz="1200" dirty="0"/>
+          </a:p>
+        </p:txBody>
+      </p:sp>
+      <p:sp>
+        <p:nvSpPr>
+          <p:cNvPr id="17" name="Text 14"/>
+          <p:cNvSpPr/>
+          <p:nvPr/>
+        </p:nvSpPr>
+        <p:spPr>
+          <a:xfrm>
+            <a:off x="3172968" y="5925312"/>
+            <a:ext cx="1517904" cy="347472"/>
+          </a:xfrm>
+          <a:prstGeom prst="rect">
+            <a:avLst/>
+          </a:prstGeom>
+          <a:noFill/>
+          <a:ln/>
+        </p:spPr>
+        <p:txBody>
+          <a:bodyPr wrap="square" rtlCol="0" anchor="ctr"/>
+          <a:lstStyle/>
+          <a:p>
+            <a:pPr algn="ctr" indent="0" marL="0">
+              <a:buNone/>
+            </a:pPr>
+            <a:r>
+              <a:rPr lang="en-US" sz="1200" b="1" dirty="0">
+                <a:solidFill>
+                  <a:srgbClr val="1A7A6E"/>
+                </a:solidFill>
+                <a:latin typeface="Calibri" pitchFamily="34" charset="0"/>
+                <a:ea typeface="Calibri" pitchFamily="34" charset="-122"/>
+                <a:cs typeface="Calibri" pitchFamily="34" charset="-120"/>
+              </a:rPr>
               <a:t>—</a:t>
             </a:r>
             <a:endParaRPr lang="en-US" sz="1200" dirty="0"/>
@@ -17356,13 +17395,13 @@
       </p:sp>
       <p:sp>
         <p:nvSpPr>
-          <p:cNvPr id="17" name="Text 14"/>
-          <p:cNvSpPr/>
-          <p:nvPr/>
-        </p:nvSpPr>
-        <p:spPr>
-          <a:xfrm>
-            <a:off x="3172968" y="5925312"/>
+          <p:cNvPr id="18" name="Text 15"/>
+          <p:cNvSpPr/>
+          <p:nvPr/>
+        </p:nvSpPr>
+        <p:spPr>
+          <a:xfrm>
+            <a:off x="4690872" y="5925312"/>
             <a:ext cx="1517904" cy="347472"/>
           </a:xfrm>
           <a:prstGeom prst="rect">
@@ -17395,13 +17434,13 @@
       </p:sp>
       <p:sp>
         <p:nvSpPr>
-          <p:cNvPr id="18" name="Text 15"/>
-          <p:cNvSpPr/>
-          <p:nvPr/>
-        </p:nvSpPr>
-        <p:spPr>
-          <a:xfrm>
-            <a:off x="4690872" y="5925312"/>
+          <p:cNvPr id="19" name="Text 16"/>
+          <p:cNvSpPr/>
+          <p:nvPr/>
+        </p:nvSpPr>
+        <p:spPr>
+          <a:xfrm>
+            <a:off x="6208776" y="5925312"/>
             <a:ext cx="1517904" cy="347472"/>
           </a:xfrm>
           <a:prstGeom prst="rect">
@@ -17427,45 +17466,6 @@
                 <a:cs typeface="Calibri" pitchFamily="34" charset="-120"/>
               </a:rPr>
               <a:t>↑</a:t>
-            </a:r>
-            <a:endParaRPr lang="en-US" sz="1200" dirty="0"/>
-          </a:p>
-        </p:txBody>
-      </p:sp>
-      <p:sp>
-        <p:nvSpPr>
-          <p:cNvPr id="19" name="Text 16"/>
-          <p:cNvSpPr/>
-          <p:nvPr/>
-        </p:nvSpPr>
-        <p:spPr>
-          <a:xfrm>
-            <a:off x="6208776" y="5925312"/>
-            <a:ext cx="1517904" cy="347472"/>
-          </a:xfrm>
-          <a:prstGeom prst="rect">
-            <a:avLst/>
-          </a:prstGeom>
-          <a:noFill/>
-          <a:ln/>
-        </p:spPr>
-        <p:txBody>
-          <a:bodyPr wrap="square" rtlCol="0" anchor="ctr"/>
-          <a:lstStyle/>
-          <a:p>
-            <a:pPr algn="ctr" indent="0" marL="0">
-              <a:buNone/>
-            </a:pPr>
-            <a:r>
-              <a:rPr lang="en-US" sz="1200" b="1" dirty="0">
-                <a:solidFill>
-                  <a:srgbClr val="718096"/>
-                </a:solidFill>
-                <a:latin typeface="Calibri" pitchFamily="34" charset="0"/>
-                <a:ea typeface="Calibri" pitchFamily="34" charset="-122"/>
-                <a:cs typeface="Calibri" pitchFamily="34" charset="-120"/>
-              </a:rPr>
-              <a:t>—</a:t>
             </a:r>
             <a:endParaRPr lang="en-US" sz="1200" dirty="0"/>
           </a:p>
@@ -17561,7 +17561,7 @@
                 <a:ea typeface="Century Gothic" pitchFamily="34" charset="-122"/>
                 <a:cs typeface="Century Gothic" pitchFamily="34" charset="-120"/>
               </a:rPr>
-              <a:t>4 days</a:t>
+              <a:t>3 days</a:t>
             </a:r>
             <a:endParaRPr lang="en-US" sz="2600" dirty="0"/>
           </a:p>
@@ -17696,7 +17696,7 @@
                 <a:ea typeface="Century Gothic" pitchFamily="34" charset="-122"/>
                 <a:cs typeface="Century Gothic" pitchFamily="34" charset="-120"/>
               </a:rPr>
-              <a:t>↑</a:t>
+              <a:t>—</a:t>
             </a:r>
             <a:endParaRPr lang="en-US" sz="2600" dirty="0"/>
           </a:p>
@@ -17863,7 +17863,7 @@
                 <a:ea typeface="Calibri" pitchFamily="34" charset="-122"/>
                 <a:cs typeface="Calibri" pitchFamily="34" charset="-120"/>
               </a:rPr>
-              <a:t>Group avg turnaround: 4 days.</a:t>
+              <a:t>Group avg turnaround: 3 days.</a:t>
             </a:r>
             <a:endParaRPr lang="en-US" sz="1200" dirty="0"/>
           </a:p>
@@ -17880,7 +17880,7 @@
                 <a:ea typeface="Calibri" pitchFamily="34" charset="-122"/>
                 <a:cs typeface="Calibri" pitchFamily="34" charset="-120"/>
               </a:rPr>
-              <a:t>Fastest: Nigeria (2 days). Slowest: Sierra Leone (5 days).</a:t>
+              <a:t>Fastest: Uganda (2 days). Slowest: Sierra Leone (5 days).</a:t>
             </a:r>
             <a:endParaRPr lang="en-US" sz="1200" dirty="0"/>
           </a:p>
@@ -18441,6 +18441,45 @@
             <a:r>
               <a:rPr lang="en-US" sz="1200" b="1" dirty="0">
                 <a:solidFill>
+                  <a:srgbClr val="C0392B"/>
+                </a:solidFill>
+                <a:latin typeface="Calibri" pitchFamily="34" charset="0"/>
+                <a:ea typeface="Calibri" pitchFamily="34" charset="-122"/>
+                <a:cs typeface="Calibri" pitchFamily="34" charset="-120"/>
+              </a:rPr>
+              <a:t>-4.8%</a:t>
+            </a:r>
+            <a:endParaRPr lang="en-US" sz="1200" dirty="0"/>
+          </a:p>
+        </p:txBody>
+      </p:sp>
+      <p:sp>
+        <p:nvSpPr>
+          <p:cNvPr id="19" name="Text 16"/>
+          <p:cNvSpPr/>
+          <p:nvPr/>
+        </p:nvSpPr>
+        <p:spPr>
+          <a:xfrm>
+            <a:off x="6208776" y="5925312"/>
+            <a:ext cx="1517904" cy="347472"/>
+          </a:xfrm>
+          <a:prstGeom prst="rect">
+            <a:avLst/>
+          </a:prstGeom>
+          <a:noFill/>
+          <a:ln/>
+        </p:spPr>
+        <p:txBody>
+          <a:bodyPr wrap="square" rtlCol="0" anchor="ctr"/>
+          <a:lstStyle/>
+          <a:p>
+            <a:pPr algn="ctr" indent="0" marL="0">
+              <a:buNone/>
+            </a:pPr>
+            <a:r>
+              <a:rPr lang="en-US" sz="1200" b="1" dirty="0">
+                <a:solidFill>
                   <a:srgbClr val="1A7A6E"/>
                 </a:solidFill>
                 <a:latin typeface="Calibri" pitchFamily="34" charset="0"/>
@@ -18448,45 +18487,6 @@
                 <a:cs typeface="Calibri" pitchFamily="34" charset="-120"/>
               </a:rPr>
               <a:t>+0.4%</a:t>
-            </a:r>
-            <a:endParaRPr lang="en-US" sz="1200" dirty="0"/>
-          </a:p>
-        </p:txBody>
-      </p:sp>
-      <p:sp>
-        <p:nvSpPr>
-          <p:cNvPr id="19" name="Text 16"/>
-          <p:cNvSpPr/>
-          <p:nvPr/>
-        </p:nvSpPr>
-        <p:spPr>
-          <a:xfrm>
-            <a:off x="6208776" y="5925312"/>
-            <a:ext cx="1517904" cy="347472"/>
-          </a:xfrm>
-          <a:prstGeom prst="rect">
-            <a:avLst/>
-          </a:prstGeom>
-          <a:noFill/>
-          <a:ln/>
-        </p:spPr>
-        <p:txBody>
-          <a:bodyPr wrap="square" rtlCol="0" anchor="ctr"/>
-          <a:lstStyle/>
-          <a:p>
-            <a:pPr algn="ctr" indent="0" marL="0">
-              <a:buNone/>
-            </a:pPr>
-            <a:r>
-              <a:rPr lang="en-US" sz="1200" b="1" dirty="0">
-                <a:solidFill>
-                  <a:srgbClr val="718096"/>
-                </a:solidFill>
-                <a:latin typeface="Calibri" pitchFamily="34" charset="0"/>
-                <a:ea typeface="Calibri" pitchFamily="34" charset="-122"/>
-                <a:cs typeface="Calibri" pitchFamily="34" charset="-120"/>
-              </a:rPr>
-              <a:t>—</a:t>
             </a:r>
             <a:endParaRPr lang="en-US" sz="1200" dirty="0"/>
           </a:p>
@@ -18582,7 +18582,7 @@
                 <a:ea typeface="Century Gothic" pitchFamily="34" charset="-122"/>
                 <a:cs typeface="Century Gothic" pitchFamily="34" charset="-120"/>
               </a:rPr>
-              <a:t>$10,958,236</a:t>
+              <a:t>$12,257,060</a:t>
             </a:r>
             <a:endParaRPr lang="en-US" sz="2600" dirty="0"/>
           </a:p>
@@ -18717,7 +18717,7 @@
                 <a:ea typeface="Century Gothic" pitchFamily="34" charset="-122"/>
                 <a:cs typeface="Century Gothic" pitchFamily="34" charset="-120"/>
               </a:rPr>
-              <a:t>+5.9%</a:t>
+              <a:t>+4.7%</a:t>
             </a:r>
             <a:endParaRPr lang="en-US" sz="2600" dirty="0"/>
           </a:p>
@@ -18884,7 +18884,7 @@
                 <a:ea typeface="Calibri" pitchFamily="34" charset="-122"/>
                 <a:cs typeface="Calibri" pitchFamily="34" charset="-120"/>
               </a:rPr>
-              <a:t>Total loan book: $10,958,236 (+5.9% vs prior month).</a:t>
+              <a:t>Total loan book: $12,257,060 (+4.7% vs prior month).</a:t>
             </a:r>
             <a:endParaRPr lang="en-US" sz="1200" dirty="0"/>
           </a:p>
@@ -19533,280 +19533,6 @@
                           <a:ea typeface="Century Gothic" pitchFamily="34" charset="-122"/>
                           <a:cs typeface="Century Gothic" pitchFamily="34" charset="-120"/>
                         </a:rPr>
-                        <a:t>Uganda</a:t>
-                      </a:r>
-                      <a:endParaRPr lang="en-US" sz="1200" dirty="0">
-                        <a:latin typeface="Century Gothic" charset="0"/>
-                        <a:ea typeface="Century Gothic" charset="0"/>
-                        <a:cs typeface="Century Gothic" charset="0"/>
-                      </a:endParaRPr>
-                    </a:p>
-                  </a:txBody>
-                  <a:tcPr marL="91440" marR="91440" marT="45720" marB="45720" anchor="ctr">
-                    <a:lnL w="6350" cap="flat" cmpd="sng" algn="ctr">
-                      <a:solidFill>
-                        <a:srgbClr val="D6CFC4"/>
-                      </a:solidFill>
-                      <a:prstDash val="solid"/>
-                      <a:round/>
-                      <a:headEnd type="none" w="med" len="med"/>
-                      <a:tailEnd type="none" w="med" len="med"/>
-                    </a:lnL>
-                    <a:lnR w="6350" cap="flat" cmpd="sng" algn="ctr">
-                      <a:solidFill>
-                        <a:srgbClr val="D6CFC4"/>
-                      </a:solidFill>
-                      <a:prstDash val="solid"/>
-                      <a:round/>
-                      <a:headEnd type="none" w="med" len="med"/>
-                      <a:tailEnd type="none" w="med" len="med"/>
-                    </a:lnR>
-                    <a:lnT w="6350" cap="flat" cmpd="sng" algn="ctr">
-                      <a:solidFill>
-                        <a:srgbClr val="D6CFC4"/>
-                      </a:solidFill>
-                      <a:prstDash val="solid"/>
-                      <a:round/>
-                      <a:headEnd type="none" w="med" len="med"/>
-                      <a:tailEnd type="none" w="med" len="med"/>
-                    </a:lnT>
-                    <a:lnB w="6350" cap="flat" cmpd="sng" algn="ctr">
-                      <a:solidFill>
-                        <a:srgbClr val="D6CFC4"/>
-                      </a:solidFill>
-                      <a:prstDash val="solid"/>
-                      <a:round/>
-                      <a:headEnd type="none" w="med" len="med"/>
-                      <a:tailEnd type="none" w="med" len="med"/>
-                    </a:lnB>
-                    <a:solidFill>
-                      <a:srgbClr val="FFFFFF"/>
-                    </a:solidFill>
-                  </a:tcPr>
-                </a:tc>
-                <a:tc>
-                  <a:txBody>
-                    <a:bodyPr/>
-                    <a:lstStyle/>
-                    <a:p>
-                      <a:pPr algn="ctr" indent="0" marL="0">
-                        <a:buNone/>
-                      </a:pPr>
-                      <a:r>
-                        <a:rPr lang="en-US" sz="1200" dirty="0">
-                          <a:solidFill>
-                            <a:srgbClr val="2D2A26"/>
-                          </a:solidFill>
-                          <a:latin typeface="Calibri" pitchFamily="34" charset="0"/>
-                          <a:ea typeface="Calibri" pitchFamily="34" charset="-122"/>
-                          <a:cs typeface="Calibri" pitchFamily="34" charset="-120"/>
-                        </a:rPr>
-                        <a:t>—</a:t>
-                      </a:r>
-                      <a:endParaRPr lang="en-US" sz="1200" dirty="0">
-                        <a:latin typeface="Calibri" charset="0"/>
-                        <a:ea typeface="Calibri" charset="0"/>
-                        <a:cs typeface="Calibri" charset="0"/>
-                      </a:endParaRPr>
-                    </a:p>
-                  </a:txBody>
-                  <a:tcPr marL="91440" marR="91440" marT="45720" marB="45720" anchor="ctr">
-                    <a:lnL w="6350" cap="flat" cmpd="sng" algn="ctr">
-                      <a:solidFill>
-                        <a:srgbClr val="D6CFC4"/>
-                      </a:solidFill>
-                      <a:prstDash val="solid"/>
-                      <a:round/>
-                      <a:headEnd type="none" w="med" len="med"/>
-                      <a:tailEnd type="none" w="med" len="med"/>
-                    </a:lnL>
-                    <a:lnR w="6350" cap="flat" cmpd="sng" algn="ctr">
-                      <a:solidFill>
-                        <a:srgbClr val="D6CFC4"/>
-                      </a:solidFill>
-                      <a:prstDash val="solid"/>
-                      <a:round/>
-                      <a:headEnd type="none" w="med" len="med"/>
-                      <a:tailEnd type="none" w="med" len="med"/>
-                    </a:lnR>
-                    <a:lnT w="6350" cap="flat" cmpd="sng" algn="ctr">
-                      <a:solidFill>
-                        <a:srgbClr val="D6CFC4"/>
-                      </a:solidFill>
-                      <a:prstDash val="solid"/>
-                      <a:round/>
-                      <a:headEnd type="none" w="med" len="med"/>
-                      <a:tailEnd type="none" w="med" len="med"/>
-                    </a:lnT>
-                    <a:lnB w="6350" cap="flat" cmpd="sng" algn="ctr">
-                      <a:solidFill>
-                        <a:srgbClr val="D6CFC4"/>
-                      </a:solidFill>
-                      <a:prstDash val="solid"/>
-                      <a:round/>
-                      <a:headEnd type="none" w="med" len="med"/>
-                      <a:tailEnd type="none" w="med" len="med"/>
-                    </a:lnB>
-                    <a:solidFill>
-                      <a:srgbClr val="FFFFFF"/>
-                    </a:solidFill>
-                  </a:tcPr>
-                </a:tc>
-                <a:tc>
-                  <a:txBody>
-                    <a:bodyPr/>
-                    <a:lstStyle/>
-                    <a:p>
-                      <a:pPr algn="ctr" indent="0" marL="0">
-                        <a:buNone/>
-                      </a:pPr>
-                      <a:r>
-                        <a:rPr lang="en-US" sz="1200" dirty="0">
-                          <a:solidFill>
-                            <a:srgbClr val="2D2A26"/>
-                          </a:solidFill>
-                          <a:latin typeface="Calibri" pitchFamily="34" charset="0"/>
-                          <a:ea typeface="Calibri" pitchFamily="34" charset="-122"/>
-                          <a:cs typeface="Calibri" pitchFamily="34" charset="-120"/>
-                        </a:rPr>
-                        <a:t>—</a:t>
-                      </a:r>
-                      <a:endParaRPr lang="en-US" sz="1200" dirty="0">
-                        <a:latin typeface="Calibri" charset="0"/>
-                        <a:ea typeface="Calibri" charset="0"/>
-                        <a:cs typeface="Calibri" charset="0"/>
-                      </a:endParaRPr>
-                    </a:p>
-                  </a:txBody>
-                  <a:tcPr marL="91440" marR="91440" marT="45720" marB="45720" anchor="ctr">
-                    <a:lnL w="6350" cap="flat" cmpd="sng" algn="ctr">
-                      <a:solidFill>
-                        <a:srgbClr val="D6CFC4"/>
-                      </a:solidFill>
-                      <a:prstDash val="solid"/>
-                      <a:round/>
-                      <a:headEnd type="none" w="med" len="med"/>
-                      <a:tailEnd type="none" w="med" len="med"/>
-                    </a:lnL>
-                    <a:lnR w="6350" cap="flat" cmpd="sng" algn="ctr">
-                      <a:solidFill>
-                        <a:srgbClr val="D6CFC4"/>
-                      </a:solidFill>
-                      <a:prstDash val="solid"/>
-                      <a:round/>
-                      <a:headEnd type="none" w="med" len="med"/>
-                      <a:tailEnd type="none" w="med" len="med"/>
-                    </a:lnR>
-                    <a:lnT w="6350" cap="flat" cmpd="sng" algn="ctr">
-                      <a:solidFill>
-                        <a:srgbClr val="D6CFC4"/>
-                      </a:solidFill>
-                      <a:prstDash val="solid"/>
-                      <a:round/>
-                      <a:headEnd type="none" w="med" len="med"/>
-                      <a:tailEnd type="none" w="med" len="med"/>
-                    </a:lnT>
-                    <a:lnB w="6350" cap="flat" cmpd="sng" algn="ctr">
-                      <a:solidFill>
-                        <a:srgbClr val="D6CFC4"/>
-                      </a:solidFill>
-                      <a:prstDash val="solid"/>
-                      <a:round/>
-                      <a:headEnd type="none" w="med" len="med"/>
-                      <a:tailEnd type="none" w="med" len="med"/>
-                    </a:lnB>
-                    <a:solidFill>
-                      <a:srgbClr val="FFFFFF"/>
-                    </a:solidFill>
-                  </a:tcPr>
-                </a:tc>
-                <a:tc>
-                  <a:txBody>
-                    <a:bodyPr/>
-                    <a:lstStyle/>
-                    <a:p>
-                      <a:pPr algn="ctr" indent="0" marL="0">
-                        <a:buNone/>
-                      </a:pPr>
-                      <a:r>
-                        <a:rPr lang="en-US" sz="1200" dirty="0">
-                          <a:solidFill>
-                            <a:srgbClr val="718096"/>
-                          </a:solidFill>
-                          <a:latin typeface="Calibri" pitchFamily="34" charset="0"/>
-                          <a:ea typeface="Calibri" pitchFamily="34" charset="-122"/>
-                          <a:cs typeface="Calibri" pitchFamily="34" charset="-120"/>
-                        </a:rPr>
-                        <a:t>—</a:t>
-                      </a:r>
-                      <a:endParaRPr lang="en-US" sz="1200" dirty="0">
-                        <a:latin typeface="Calibri" charset="0"/>
-                        <a:ea typeface="Calibri" charset="0"/>
-                        <a:cs typeface="Calibri" charset="0"/>
-                      </a:endParaRPr>
-                    </a:p>
-                  </a:txBody>
-                  <a:tcPr marL="91440" marR="91440" marT="45720" marB="45720" anchor="ctr">
-                    <a:lnL w="6350" cap="flat" cmpd="sng" algn="ctr">
-                      <a:solidFill>
-                        <a:srgbClr val="D6CFC4"/>
-                      </a:solidFill>
-                      <a:prstDash val="solid"/>
-                      <a:round/>
-                      <a:headEnd type="none" w="med" len="med"/>
-                      <a:tailEnd type="none" w="med" len="med"/>
-                    </a:lnL>
-                    <a:lnR w="6350" cap="flat" cmpd="sng" algn="ctr">
-                      <a:solidFill>
-                        <a:srgbClr val="D6CFC4"/>
-                      </a:solidFill>
-                      <a:prstDash val="solid"/>
-                      <a:round/>
-                      <a:headEnd type="none" w="med" len="med"/>
-                      <a:tailEnd type="none" w="med" len="med"/>
-                    </a:lnR>
-                    <a:lnT w="6350" cap="flat" cmpd="sng" algn="ctr">
-                      <a:solidFill>
-                        <a:srgbClr val="D6CFC4"/>
-                      </a:solidFill>
-                      <a:prstDash val="solid"/>
-                      <a:round/>
-                      <a:headEnd type="none" w="med" len="med"/>
-                      <a:tailEnd type="none" w="med" len="med"/>
-                    </a:lnT>
-                    <a:lnB w="6350" cap="flat" cmpd="sng" algn="ctr">
-                      <a:solidFill>
-                        <a:srgbClr val="D6CFC4"/>
-                      </a:solidFill>
-                      <a:prstDash val="solid"/>
-                      <a:round/>
-                      <a:headEnd type="none" w="med" len="med"/>
-                      <a:tailEnd type="none" w="med" len="med"/>
-                    </a:lnB>
-                    <a:solidFill>
-                      <a:srgbClr val="FFFFFF"/>
-                    </a:solidFill>
-                  </a:tcPr>
-                </a:tc>
-              </a:tr>
-              <a:tr h="384048">
-                <a:tc>
-                  <a:txBody>
-                    <a:bodyPr/>
-                    <a:lstStyle/>
-                    <a:p>
-                      <a:pPr algn="l" indent="0" marL="0">
-                        <a:buNone/>
-                      </a:pPr>
-                      <a:r>
-                        <a:rPr lang="en-US" sz="1200" b="1" dirty="0">
-                          <a:solidFill>
-                            <a:srgbClr val="2D2A26"/>
-                          </a:solidFill>
-                          <a:latin typeface="Century Gothic" pitchFamily="34" charset="0"/>
-                          <a:ea typeface="Century Gothic" pitchFamily="34" charset="-122"/>
-                          <a:cs typeface="Century Gothic" pitchFamily="34" charset="-120"/>
-                        </a:rPr>
                         <a:t>Sierra Leone</a:t>
                       </a:r>
                       <a:endParaRPr lang="en-US" sz="1200" dirty="0">
@@ -19854,7 +19580,7 @@
                       <a:tailEnd type="none" w="med" len="med"/>
                     </a:lnB>
                     <a:solidFill>
-                      <a:srgbClr val="FFF9D9"/>
+                      <a:srgbClr val="FFFFFF"/>
                     </a:solidFill>
                   </a:tcPr>
                 </a:tc>
@@ -19922,7 +19648,7 @@
                       <a:tailEnd type="none" w="med" len="med"/>
                     </a:lnB>
                     <a:solidFill>
-                      <a:srgbClr val="FFF9D9"/>
+                      <a:srgbClr val="FFFFFF"/>
                     </a:solidFill>
                   </a:tcPr>
                 </a:tc>
@@ -19990,7 +19716,7 @@
                       <a:tailEnd type="none" w="med" len="med"/>
                     </a:lnB>
                     <a:solidFill>
-                      <a:srgbClr val="FFF9D9"/>
+                      <a:srgbClr val="FFFFFF"/>
                     </a:solidFill>
                   </a:tcPr>
                 </a:tc>
@@ -20058,7 +19784,7 @@
                       <a:tailEnd type="none" w="med" len="med"/>
                     </a:lnB>
                     <a:solidFill>
-                      <a:srgbClr val="FFF9D9"/>
+                      <a:srgbClr val="FFFFFF"/>
                     </a:solidFill>
                   </a:tcPr>
                 </a:tc>
@@ -20128,7 +19854,7 @@
                       <a:tailEnd type="none" w="med" len="med"/>
                     </a:lnB>
                     <a:solidFill>
-                      <a:srgbClr val="FFFFFF"/>
+                      <a:srgbClr val="FFF9D9"/>
                     </a:solidFill>
                   </a:tcPr>
                 </a:tc>
@@ -20196,7 +19922,7 @@
                       <a:tailEnd type="none" w="med" len="med"/>
                     </a:lnB>
                     <a:solidFill>
-                      <a:srgbClr val="FFFFFF"/>
+                      <a:srgbClr val="FFF9D9"/>
                     </a:solidFill>
                   </a:tcPr>
                 </a:tc>
@@ -20264,7 +19990,7 @@
                       <a:tailEnd type="none" w="med" len="med"/>
                     </a:lnB>
                     <a:solidFill>
-                      <a:srgbClr val="FFFFFF"/>
+                      <a:srgbClr val="FFF9D9"/>
                     </a:solidFill>
                   </a:tcPr>
                 </a:tc>
@@ -20332,7 +20058,7 @@
                       <a:tailEnd type="none" w="med" len="med"/>
                     </a:lnB>
                     <a:solidFill>
-                      <a:srgbClr val="FFFFFF"/>
+                      <a:srgbClr val="FFF9D9"/>
                     </a:solidFill>
                   </a:tcPr>
                 </a:tc>
@@ -20402,7 +20128,7 @@
                       <a:tailEnd type="none" w="med" len="med"/>
                     </a:lnB>
                     <a:solidFill>
-                      <a:srgbClr val="FFF9D9"/>
+                      <a:srgbClr val="FFFFFF"/>
                     </a:solidFill>
                   </a:tcPr>
                 </a:tc>
@@ -20470,6 +20196,212 @@
                       <a:tailEnd type="none" w="med" len="med"/>
                     </a:lnB>
                     <a:solidFill>
+                      <a:srgbClr val="FFFFFF"/>
+                    </a:solidFill>
+                  </a:tcPr>
+                </a:tc>
+                <a:tc>
+                  <a:txBody>
+                    <a:bodyPr/>
+                    <a:lstStyle/>
+                    <a:p>
+                      <a:pPr algn="ctr" indent="0" marL="0">
+                        <a:buNone/>
+                      </a:pPr>
+                      <a:r>
+                        <a:rPr lang="en-US" sz="1200" dirty="0">
+                          <a:solidFill>
+                            <a:srgbClr val="2D2A26"/>
+                          </a:solidFill>
+                          <a:latin typeface="Calibri" pitchFamily="34" charset="0"/>
+                          <a:ea typeface="Calibri" pitchFamily="34" charset="-122"/>
+                          <a:cs typeface="Calibri" pitchFamily="34" charset="-120"/>
+                        </a:rPr>
+                        <a:t>9.5%</a:t>
+                      </a:r>
+                      <a:endParaRPr lang="en-US" sz="1200" dirty="0">
+                        <a:latin typeface="Calibri" charset="0"/>
+                        <a:ea typeface="Calibri" charset="0"/>
+                        <a:cs typeface="Calibri" charset="0"/>
+                      </a:endParaRPr>
+                    </a:p>
+                  </a:txBody>
+                  <a:tcPr marL="91440" marR="91440" marT="45720" marB="45720" anchor="ctr">
+                    <a:lnL w="6350" cap="flat" cmpd="sng" algn="ctr">
+                      <a:solidFill>
+                        <a:srgbClr val="D6CFC4"/>
+                      </a:solidFill>
+                      <a:prstDash val="solid"/>
+                      <a:round/>
+                      <a:headEnd type="none" w="med" len="med"/>
+                      <a:tailEnd type="none" w="med" len="med"/>
+                    </a:lnL>
+                    <a:lnR w="6350" cap="flat" cmpd="sng" algn="ctr">
+                      <a:solidFill>
+                        <a:srgbClr val="D6CFC4"/>
+                      </a:solidFill>
+                      <a:prstDash val="solid"/>
+                      <a:round/>
+                      <a:headEnd type="none" w="med" len="med"/>
+                      <a:tailEnd type="none" w="med" len="med"/>
+                    </a:lnR>
+                    <a:lnT w="6350" cap="flat" cmpd="sng" algn="ctr">
+                      <a:solidFill>
+                        <a:srgbClr val="D6CFC4"/>
+                      </a:solidFill>
+                      <a:prstDash val="solid"/>
+                      <a:round/>
+                      <a:headEnd type="none" w="med" len="med"/>
+                      <a:tailEnd type="none" w="med" len="med"/>
+                    </a:lnT>
+                    <a:lnB w="6350" cap="flat" cmpd="sng" algn="ctr">
+                      <a:solidFill>
+                        <a:srgbClr val="D6CFC4"/>
+                      </a:solidFill>
+                      <a:prstDash val="solid"/>
+                      <a:round/>
+                      <a:headEnd type="none" w="med" len="med"/>
+                      <a:tailEnd type="none" w="med" len="med"/>
+                    </a:lnB>
+                    <a:solidFill>
+                      <a:srgbClr val="FFFFFF"/>
+                    </a:solidFill>
+                  </a:tcPr>
+                </a:tc>
+                <a:tc>
+                  <a:txBody>
+                    <a:bodyPr/>
+                    <a:lstStyle/>
+                    <a:p>
+                      <a:pPr algn="ctr" indent="0" marL="0">
+                        <a:buNone/>
+                      </a:pPr>
+                      <a:r>
+                        <a:rPr lang="en-US" sz="1200" dirty="0">
+                          <a:solidFill>
+                            <a:srgbClr val="1A7A6E"/>
+                          </a:solidFill>
+                          <a:latin typeface="Calibri" pitchFamily="34" charset="0"/>
+                          <a:ea typeface="Calibri" pitchFamily="34" charset="-122"/>
+                          <a:cs typeface="Calibri" pitchFamily="34" charset="-120"/>
+                        </a:rPr>
+                        <a:t>↓</a:t>
+                      </a:r>
+                      <a:endParaRPr lang="en-US" sz="1200" dirty="0">
+                        <a:latin typeface="Calibri" charset="0"/>
+                        <a:ea typeface="Calibri" charset="0"/>
+                        <a:cs typeface="Calibri" charset="0"/>
+                      </a:endParaRPr>
+                    </a:p>
+                  </a:txBody>
+                  <a:tcPr marL="91440" marR="91440" marT="45720" marB="45720" anchor="ctr">
+                    <a:lnL w="6350" cap="flat" cmpd="sng" algn="ctr">
+                      <a:solidFill>
+                        <a:srgbClr val="D6CFC4"/>
+                      </a:solidFill>
+                      <a:prstDash val="solid"/>
+                      <a:round/>
+                      <a:headEnd type="none" w="med" len="med"/>
+                      <a:tailEnd type="none" w="med" len="med"/>
+                    </a:lnL>
+                    <a:lnR w="6350" cap="flat" cmpd="sng" algn="ctr">
+                      <a:solidFill>
+                        <a:srgbClr val="D6CFC4"/>
+                      </a:solidFill>
+                      <a:prstDash val="solid"/>
+                      <a:round/>
+                      <a:headEnd type="none" w="med" len="med"/>
+                      <a:tailEnd type="none" w="med" len="med"/>
+                    </a:lnR>
+                    <a:lnT w="6350" cap="flat" cmpd="sng" algn="ctr">
+                      <a:solidFill>
+                        <a:srgbClr val="D6CFC4"/>
+                      </a:solidFill>
+                      <a:prstDash val="solid"/>
+                      <a:round/>
+                      <a:headEnd type="none" w="med" len="med"/>
+                      <a:tailEnd type="none" w="med" len="med"/>
+                    </a:lnT>
+                    <a:lnB w="6350" cap="flat" cmpd="sng" algn="ctr">
+                      <a:solidFill>
+                        <a:srgbClr val="D6CFC4"/>
+                      </a:solidFill>
+                      <a:prstDash val="solid"/>
+                      <a:round/>
+                      <a:headEnd type="none" w="med" len="med"/>
+                      <a:tailEnd type="none" w="med" len="med"/>
+                    </a:lnB>
+                    <a:solidFill>
+                      <a:srgbClr val="FFFFFF"/>
+                    </a:solidFill>
+                  </a:tcPr>
+                </a:tc>
+              </a:tr>
+              <a:tr h="384048">
+                <a:tc>
+                  <a:txBody>
+                    <a:bodyPr/>
+                    <a:lstStyle/>
+                    <a:p>
+                      <a:pPr algn="l" indent="0" marL="0">
+                        <a:buNone/>
+                      </a:pPr>
+                      <a:r>
+                        <a:rPr lang="en-US" sz="1200" b="1" dirty="0">
+                          <a:solidFill>
+                            <a:srgbClr val="2D2A26"/>
+                          </a:solidFill>
+                          <a:latin typeface="Century Gothic" pitchFamily="34" charset="0"/>
+                          <a:ea typeface="Century Gothic" pitchFamily="34" charset="-122"/>
+                          <a:cs typeface="Century Gothic" pitchFamily="34" charset="-120"/>
+                        </a:rPr>
+                        <a:t>Uganda</a:t>
+                      </a:r>
+                      <a:endParaRPr lang="en-US" sz="1200" dirty="0">
+                        <a:latin typeface="Century Gothic" charset="0"/>
+                        <a:ea typeface="Century Gothic" charset="0"/>
+                        <a:cs typeface="Century Gothic" charset="0"/>
+                      </a:endParaRPr>
+                    </a:p>
+                  </a:txBody>
+                  <a:tcPr marL="91440" marR="91440" marT="45720" marB="45720" anchor="ctr">
+                    <a:lnL w="6350" cap="flat" cmpd="sng" algn="ctr">
+                      <a:solidFill>
+                        <a:srgbClr val="D6CFC4"/>
+                      </a:solidFill>
+                      <a:prstDash val="solid"/>
+                      <a:round/>
+                      <a:headEnd type="none" w="med" len="med"/>
+                      <a:tailEnd type="none" w="med" len="med"/>
+                    </a:lnL>
+                    <a:lnR w="6350" cap="flat" cmpd="sng" algn="ctr">
+                      <a:solidFill>
+                        <a:srgbClr val="D6CFC4"/>
+                      </a:solidFill>
+                      <a:prstDash val="solid"/>
+                      <a:round/>
+                      <a:headEnd type="none" w="med" len="med"/>
+                      <a:tailEnd type="none" w="med" len="med"/>
+                    </a:lnR>
+                    <a:lnT w="6350" cap="flat" cmpd="sng" algn="ctr">
+                      <a:solidFill>
+                        <a:srgbClr val="D6CFC4"/>
+                      </a:solidFill>
+                      <a:prstDash val="solid"/>
+                      <a:round/>
+                      <a:headEnd type="none" w="med" len="med"/>
+                      <a:tailEnd type="none" w="med" len="med"/>
+                    </a:lnT>
+                    <a:lnB w="6350" cap="flat" cmpd="sng" algn="ctr">
+                      <a:solidFill>
+                        <a:srgbClr val="D6CFC4"/>
+                      </a:solidFill>
+                      <a:prstDash val="solid"/>
+                      <a:round/>
+                      <a:headEnd type="none" w="med" len="med"/>
+                      <a:tailEnd type="none" w="med" len="med"/>
+                    </a:lnB>
+                    <a:solidFill>
                       <a:srgbClr val="FFF9D9"/>
                     </a:solidFill>
                   </a:tcPr>
@@ -20491,7 +20423,75 @@
                           <a:ea typeface="Calibri" pitchFamily="34" charset="-122"/>
                           <a:cs typeface="Calibri" pitchFamily="34" charset="-120"/>
                         </a:rPr>
-                        <a:t>9.5%</a:t>
+                        <a:t>12.4%</a:t>
+                      </a:r>
+                      <a:endParaRPr lang="en-US" sz="1200" dirty="0">
+                        <a:latin typeface="Calibri" charset="0"/>
+                        <a:ea typeface="Calibri" charset="0"/>
+                        <a:cs typeface="Calibri" charset="0"/>
+                      </a:endParaRPr>
+                    </a:p>
+                  </a:txBody>
+                  <a:tcPr marL="91440" marR="91440" marT="45720" marB="45720" anchor="ctr">
+                    <a:lnL w="6350" cap="flat" cmpd="sng" algn="ctr">
+                      <a:solidFill>
+                        <a:srgbClr val="D6CFC4"/>
+                      </a:solidFill>
+                      <a:prstDash val="solid"/>
+                      <a:round/>
+                      <a:headEnd type="none" w="med" len="med"/>
+                      <a:tailEnd type="none" w="med" len="med"/>
+                    </a:lnL>
+                    <a:lnR w="6350" cap="flat" cmpd="sng" algn="ctr">
+                      <a:solidFill>
+                        <a:srgbClr val="D6CFC4"/>
+                      </a:solidFill>
+                      <a:prstDash val="solid"/>
+                      <a:round/>
+                      <a:headEnd type="none" w="med" len="med"/>
+                      <a:tailEnd type="none" w="med" len="med"/>
+                    </a:lnR>
+                    <a:lnT w="6350" cap="flat" cmpd="sng" algn="ctr">
+                      <a:solidFill>
+                        <a:srgbClr val="D6CFC4"/>
+                      </a:solidFill>
+                      <a:prstDash val="solid"/>
+                      <a:round/>
+                      <a:headEnd type="none" w="med" len="med"/>
+                      <a:tailEnd type="none" w="med" len="med"/>
+                    </a:lnT>
+                    <a:lnB w="6350" cap="flat" cmpd="sng" algn="ctr">
+                      <a:solidFill>
+                        <a:srgbClr val="D6CFC4"/>
+                      </a:solidFill>
+                      <a:prstDash val="solid"/>
+                      <a:round/>
+                      <a:headEnd type="none" w="med" len="med"/>
+                      <a:tailEnd type="none" w="med" len="med"/>
+                    </a:lnB>
+                    <a:solidFill>
+                      <a:srgbClr val="FFF9D9"/>
+                    </a:solidFill>
+                  </a:tcPr>
+                </a:tc>
+                <a:tc>
+                  <a:txBody>
+                    <a:bodyPr/>
+                    <a:lstStyle/>
+                    <a:p>
+                      <a:pPr algn="ctr" indent="0" marL="0">
+                        <a:buNone/>
+                      </a:pPr>
+                      <a:r>
+                        <a:rPr lang="en-US" sz="1200" dirty="0">
+                          <a:solidFill>
+                            <a:srgbClr val="2D2A26"/>
+                          </a:solidFill>
+                          <a:latin typeface="Calibri" pitchFamily="34" charset="0"/>
+                          <a:ea typeface="Calibri" pitchFamily="34" charset="-122"/>
+                          <a:cs typeface="Calibri" pitchFamily="34" charset="-120"/>
+                        </a:rPr>
+                        <a:t>12.1%</a:t>
                       </a:r>
                       <a:endParaRPr lang="en-US" sz="1200" dirty="0">
                         <a:latin typeface="Calibri" charset="0"/>
@@ -20971,7 +20971,7 @@
                           <a:ea typeface="Calibri" pitchFamily="34" charset="-122"/>
                           <a:cs typeface="Calibri" pitchFamily="34" charset="-120"/>
                         </a:rPr>
-                        <a:t>8.3%</a:t>
+                        <a:t>8.8%</a:t>
                       </a:r>
                       <a:endParaRPr lang="en-US" sz="1200" dirty="0">
                         <a:latin typeface="Calibri" charset="0"/>
@@ -21039,7 +21039,7 @@
                           <a:ea typeface="Calibri" pitchFamily="34" charset="-122"/>
                           <a:cs typeface="Calibri" pitchFamily="34" charset="-120"/>
                         </a:rPr>
-                        <a:t>8.3%</a:t>
+                        <a:t>8.7%</a:t>
                       </a:r>
                       <a:endParaRPr lang="en-US" sz="1200" dirty="0">
                         <a:latin typeface="Calibri" charset="0"/>
@@ -21789,280 +21789,6 @@
                           <a:ea typeface="Century Gothic" pitchFamily="34" charset="-122"/>
                           <a:cs typeface="Century Gothic" pitchFamily="34" charset="-120"/>
                         </a:rPr>
-                        <a:t>Uganda</a:t>
-                      </a:r>
-                      <a:endParaRPr lang="en-US" sz="1200" dirty="0">
-                        <a:latin typeface="Century Gothic" charset="0"/>
-                        <a:ea typeface="Century Gothic" charset="0"/>
-                        <a:cs typeface="Century Gothic" charset="0"/>
-                      </a:endParaRPr>
-                    </a:p>
-                  </a:txBody>
-                  <a:tcPr marL="91440" marR="91440" marT="45720" marB="45720" anchor="ctr">
-                    <a:lnL w="6350" cap="flat" cmpd="sng" algn="ctr">
-                      <a:solidFill>
-                        <a:srgbClr val="D6CFC4"/>
-                      </a:solidFill>
-                      <a:prstDash val="solid"/>
-                      <a:round/>
-                      <a:headEnd type="none" w="med" len="med"/>
-                      <a:tailEnd type="none" w="med" len="med"/>
-                    </a:lnL>
-                    <a:lnR w="6350" cap="flat" cmpd="sng" algn="ctr">
-                      <a:solidFill>
-                        <a:srgbClr val="D6CFC4"/>
-                      </a:solidFill>
-                      <a:prstDash val="solid"/>
-                      <a:round/>
-                      <a:headEnd type="none" w="med" len="med"/>
-                      <a:tailEnd type="none" w="med" len="med"/>
-                    </a:lnR>
-                    <a:lnT w="6350" cap="flat" cmpd="sng" algn="ctr">
-                      <a:solidFill>
-                        <a:srgbClr val="D6CFC4"/>
-                      </a:solidFill>
-                      <a:prstDash val="solid"/>
-                      <a:round/>
-                      <a:headEnd type="none" w="med" len="med"/>
-                      <a:tailEnd type="none" w="med" len="med"/>
-                    </a:lnT>
-                    <a:lnB w="6350" cap="flat" cmpd="sng" algn="ctr">
-                      <a:solidFill>
-                        <a:srgbClr val="D6CFC4"/>
-                      </a:solidFill>
-                      <a:prstDash val="solid"/>
-                      <a:round/>
-                      <a:headEnd type="none" w="med" len="med"/>
-                      <a:tailEnd type="none" w="med" len="med"/>
-                    </a:lnB>
-                    <a:solidFill>
-                      <a:srgbClr val="FFFFFF"/>
-                    </a:solidFill>
-                  </a:tcPr>
-                </a:tc>
-                <a:tc>
-                  <a:txBody>
-                    <a:bodyPr/>
-                    <a:lstStyle/>
-                    <a:p>
-                      <a:pPr algn="ctr" indent="0" marL="0">
-                        <a:buNone/>
-                      </a:pPr>
-                      <a:r>
-                        <a:rPr lang="en-US" sz="1200" dirty="0">
-                          <a:solidFill>
-                            <a:srgbClr val="2D2A26"/>
-                          </a:solidFill>
-                          <a:latin typeface="Calibri" pitchFamily="34" charset="0"/>
-                          <a:ea typeface="Calibri" pitchFamily="34" charset="-122"/>
-                          <a:cs typeface="Calibri" pitchFamily="34" charset="-120"/>
-                        </a:rPr>
-                        <a:t>—</a:t>
-                      </a:r>
-                      <a:endParaRPr lang="en-US" sz="1200" dirty="0">
-                        <a:latin typeface="Calibri" charset="0"/>
-                        <a:ea typeface="Calibri" charset="0"/>
-                        <a:cs typeface="Calibri" charset="0"/>
-                      </a:endParaRPr>
-                    </a:p>
-                  </a:txBody>
-                  <a:tcPr marL="91440" marR="91440" marT="45720" marB="45720" anchor="ctr">
-                    <a:lnL w="6350" cap="flat" cmpd="sng" algn="ctr">
-                      <a:solidFill>
-                        <a:srgbClr val="D6CFC4"/>
-                      </a:solidFill>
-                      <a:prstDash val="solid"/>
-                      <a:round/>
-                      <a:headEnd type="none" w="med" len="med"/>
-                      <a:tailEnd type="none" w="med" len="med"/>
-                    </a:lnL>
-                    <a:lnR w="6350" cap="flat" cmpd="sng" algn="ctr">
-                      <a:solidFill>
-                        <a:srgbClr val="D6CFC4"/>
-                      </a:solidFill>
-                      <a:prstDash val="solid"/>
-                      <a:round/>
-                      <a:headEnd type="none" w="med" len="med"/>
-                      <a:tailEnd type="none" w="med" len="med"/>
-                    </a:lnR>
-                    <a:lnT w="6350" cap="flat" cmpd="sng" algn="ctr">
-                      <a:solidFill>
-                        <a:srgbClr val="D6CFC4"/>
-                      </a:solidFill>
-                      <a:prstDash val="solid"/>
-                      <a:round/>
-                      <a:headEnd type="none" w="med" len="med"/>
-                      <a:tailEnd type="none" w="med" len="med"/>
-                    </a:lnT>
-                    <a:lnB w="6350" cap="flat" cmpd="sng" algn="ctr">
-                      <a:solidFill>
-                        <a:srgbClr val="D6CFC4"/>
-                      </a:solidFill>
-                      <a:prstDash val="solid"/>
-                      <a:round/>
-                      <a:headEnd type="none" w="med" len="med"/>
-                      <a:tailEnd type="none" w="med" len="med"/>
-                    </a:lnB>
-                    <a:solidFill>
-                      <a:srgbClr val="FFFFFF"/>
-                    </a:solidFill>
-                  </a:tcPr>
-                </a:tc>
-                <a:tc>
-                  <a:txBody>
-                    <a:bodyPr/>
-                    <a:lstStyle/>
-                    <a:p>
-                      <a:pPr algn="ctr" indent="0" marL="0">
-                        <a:buNone/>
-                      </a:pPr>
-                      <a:r>
-                        <a:rPr lang="en-US" sz="1200" dirty="0">
-                          <a:solidFill>
-                            <a:srgbClr val="2D2A26"/>
-                          </a:solidFill>
-                          <a:latin typeface="Calibri" pitchFamily="34" charset="0"/>
-                          <a:ea typeface="Calibri" pitchFamily="34" charset="-122"/>
-                          <a:cs typeface="Calibri" pitchFamily="34" charset="-120"/>
-                        </a:rPr>
-                        <a:t>—</a:t>
-                      </a:r>
-                      <a:endParaRPr lang="en-US" sz="1200" dirty="0">
-                        <a:latin typeface="Calibri" charset="0"/>
-                        <a:ea typeface="Calibri" charset="0"/>
-                        <a:cs typeface="Calibri" charset="0"/>
-                      </a:endParaRPr>
-                    </a:p>
-                  </a:txBody>
-                  <a:tcPr marL="91440" marR="91440" marT="45720" marB="45720" anchor="ctr">
-                    <a:lnL w="6350" cap="flat" cmpd="sng" algn="ctr">
-                      <a:solidFill>
-                        <a:srgbClr val="D6CFC4"/>
-                      </a:solidFill>
-                      <a:prstDash val="solid"/>
-                      <a:round/>
-                      <a:headEnd type="none" w="med" len="med"/>
-                      <a:tailEnd type="none" w="med" len="med"/>
-                    </a:lnL>
-                    <a:lnR w="6350" cap="flat" cmpd="sng" algn="ctr">
-                      <a:solidFill>
-                        <a:srgbClr val="D6CFC4"/>
-                      </a:solidFill>
-                      <a:prstDash val="solid"/>
-                      <a:round/>
-                      <a:headEnd type="none" w="med" len="med"/>
-                      <a:tailEnd type="none" w="med" len="med"/>
-                    </a:lnR>
-                    <a:lnT w="6350" cap="flat" cmpd="sng" algn="ctr">
-                      <a:solidFill>
-                        <a:srgbClr val="D6CFC4"/>
-                      </a:solidFill>
-                      <a:prstDash val="solid"/>
-                      <a:round/>
-                      <a:headEnd type="none" w="med" len="med"/>
-                      <a:tailEnd type="none" w="med" len="med"/>
-                    </a:lnT>
-                    <a:lnB w="6350" cap="flat" cmpd="sng" algn="ctr">
-                      <a:solidFill>
-                        <a:srgbClr val="D6CFC4"/>
-                      </a:solidFill>
-                      <a:prstDash val="solid"/>
-                      <a:round/>
-                      <a:headEnd type="none" w="med" len="med"/>
-                      <a:tailEnd type="none" w="med" len="med"/>
-                    </a:lnB>
-                    <a:solidFill>
-                      <a:srgbClr val="FFFFFF"/>
-                    </a:solidFill>
-                  </a:tcPr>
-                </a:tc>
-                <a:tc>
-                  <a:txBody>
-                    <a:bodyPr/>
-                    <a:lstStyle/>
-                    <a:p>
-                      <a:pPr algn="ctr" indent="0" marL="0">
-                        <a:buNone/>
-                      </a:pPr>
-                      <a:r>
-                        <a:rPr lang="en-US" sz="1200" dirty="0">
-                          <a:solidFill>
-                            <a:srgbClr val="718096"/>
-                          </a:solidFill>
-                          <a:latin typeface="Calibri" pitchFamily="34" charset="0"/>
-                          <a:ea typeface="Calibri" pitchFamily="34" charset="-122"/>
-                          <a:cs typeface="Calibri" pitchFamily="34" charset="-120"/>
-                        </a:rPr>
-                        <a:t>—</a:t>
-                      </a:r>
-                      <a:endParaRPr lang="en-US" sz="1200" dirty="0">
-                        <a:latin typeface="Calibri" charset="0"/>
-                        <a:ea typeface="Calibri" charset="0"/>
-                        <a:cs typeface="Calibri" charset="0"/>
-                      </a:endParaRPr>
-                    </a:p>
-                  </a:txBody>
-                  <a:tcPr marL="91440" marR="91440" marT="45720" marB="45720" anchor="ctr">
-                    <a:lnL w="6350" cap="flat" cmpd="sng" algn="ctr">
-                      <a:solidFill>
-                        <a:srgbClr val="D6CFC4"/>
-                      </a:solidFill>
-                      <a:prstDash val="solid"/>
-                      <a:round/>
-                      <a:headEnd type="none" w="med" len="med"/>
-                      <a:tailEnd type="none" w="med" len="med"/>
-                    </a:lnL>
-                    <a:lnR w="6350" cap="flat" cmpd="sng" algn="ctr">
-                      <a:solidFill>
-                        <a:srgbClr val="D6CFC4"/>
-                      </a:solidFill>
-                      <a:prstDash val="solid"/>
-                      <a:round/>
-                      <a:headEnd type="none" w="med" len="med"/>
-                      <a:tailEnd type="none" w="med" len="med"/>
-                    </a:lnR>
-                    <a:lnT w="6350" cap="flat" cmpd="sng" algn="ctr">
-                      <a:solidFill>
-                        <a:srgbClr val="D6CFC4"/>
-                      </a:solidFill>
-                      <a:prstDash val="solid"/>
-                      <a:round/>
-                      <a:headEnd type="none" w="med" len="med"/>
-                      <a:tailEnd type="none" w="med" len="med"/>
-                    </a:lnT>
-                    <a:lnB w="6350" cap="flat" cmpd="sng" algn="ctr">
-                      <a:solidFill>
-                        <a:srgbClr val="D6CFC4"/>
-                      </a:solidFill>
-                      <a:prstDash val="solid"/>
-                      <a:round/>
-                      <a:headEnd type="none" w="med" len="med"/>
-                      <a:tailEnd type="none" w="med" len="med"/>
-                    </a:lnB>
-                    <a:solidFill>
-                      <a:srgbClr val="FFFFFF"/>
-                    </a:solidFill>
-                  </a:tcPr>
-                </a:tc>
-              </a:tr>
-              <a:tr h="384048">
-                <a:tc>
-                  <a:txBody>
-                    <a:bodyPr/>
-                    <a:lstStyle/>
-                    <a:p>
-                      <a:pPr algn="l" indent="0" marL="0">
-                        <a:buNone/>
-                      </a:pPr>
-                      <a:r>
-                        <a:rPr lang="en-US" sz="1200" b="1" dirty="0">
-                          <a:solidFill>
-                            <a:srgbClr val="2D2A26"/>
-                          </a:solidFill>
-                          <a:latin typeface="Century Gothic" pitchFamily="34" charset="0"/>
-                          <a:ea typeface="Century Gothic" pitchFamily="34" charset="-122"/>
-                          <a:cs typeface="Century Gothic" pitchFamily="34" charset="-120"/>
-                        </a:rPr>
                         <a:t>Sierra Leone</a:t>
                       </a:r>
                       <a:endParaRPr lang="en-US" sz="1200" dirty="0">
@@ -22110,7 +21836,7 @@
                       <a:tailEnd type="none" w="med" len="med"/>
                     </a:lnB>
                     <a:solidFill>
-                      <a:srgbClr val="FFF9D9"/>
+                      <a:srgbClr val="FFFFFF"/>
                     </a:solidFill>
                   </a:tcPr>
                 </a:tc>
@@ -22178,7 +21904,7 @@
                       <a:tailEnd type="none" w="med" len="med"/>
                     </a:lnB>
                     <a:solidFill>
-                      <a:srgbClr val="FFF9D9"/>
+                      <a:srgbClr val="FFFFFF"/>
                     </a:solidFill>
                   </a:tcPr>
                 </a:tc>
@@ -22246,7 +21972,7 @@
                       <a:tailEnd type="none" w="med" len="med"/>
                     </a:lnB>
                     <a:solidFill>
-                      <a:srgbClr val="FFF9D9"/>
+                      <a:srgbClr val="FFFFFF"/>
                     </a:solidFill>
                   </a:tcPr>
                 </a:tc>
@@ -22314,7 +22040,7 @@
                       <a:tailEnd type="none" w="med" len="med"/>
                     </a:lnB>
                     <a:solidFill>
-                      <a:srgbClr val="FFF9D9"/>
+                      <a:srgbClr val="FFFFFF"/>
                     </a:solidFill>
                   </a:tcPr>
                 </a:tc>
@@ -22384,7 +22110,7 @@
                       <a:tailEnd type="none" w="med" len="med"/>
                     </a:lnB>
                     <a:solidFill>
-                      <a:srgbClr val="FFFFFF"/>
+                      <a:srgbClr val="FFF9D9"/>
                     </a:solidFill>
                   </a:tcPr>
                 </a:tc>
@@ -22452,6 +22178,212 @@
                       <a:tailEnd type="none" w="med" len="med"/>
                     </a:lnB>
                     <a:solidFill>
+                      <a:srgbClr val="FFF9D9"/>
+                    </a:solidFill>
+                  </a:tcPr>
+                </a:tc>
+                <a:tc>
+                  <a:txBody>
+                    <a:bodyPr/>
+                    <a:lstStyle/>
+                    <a:p>
+                      <a:pPr algn="ctr" indent="0" marL="0">
+                        <a:buNone/>
+                      </a:pPr>
+                      <a:r>
+                        <a:rPr lang="en-US" sz="1200" dirty="0">
+                          <a:solidFill>
+                            <a:srgbClr val="2D2A26"/>
+                          </a:solidFill>
+                          <a:latin typeface="Calibri" pitchFamily="34" charset="0"/>
+                          <a:ea typeface="Calibri" pitchFamily="34" charset="-122"/>
+                          <a:cs typeface="Calibri" pitchFamily="34" charset="-120"/>
+                        </a:rPr>
+                        <a:t>6.0%</a:t>
+                      </a:r>
+                      <a:endParaRPr lang="en-US" sz="1200" dirty="0">
+                        <a:latin typeface="Calibri" charset="0"/>
+                        <a:ea typeface="Calibri" charset="0"/>
+                        <a:cs typeface="Calibri" charset="0"/>
+                      </a:endParaRPr>
+                    </a:p>
+                  </a:txBody>
+                  <a:tcPr marL="91440" marR="91440" marT="45720" marB="45720" anchor="ctr">
+                    <a:lnL w="6350" cap="flat" cmpd="sng" algn="ctr">
+                      <a:solidFill>
+                        <a:srgbClr val="D6CFC4"/>
+                      </a:solidFill>
+                      <a:prstDash val="solid"/>
+                      <a:round/>
+                      <a:headEnd type="none" w="med" len="med"/>
+                      <a:tailEnd type="none" w="med" len="med"/>
+                    </a:lnL>
+                    <a:lnR w="6350" cap="flat" cmpd="sng" algn="ctr">
+                      <a:solidFill>
+                        <a:srgbClr val="D6CFC4"/>
+                      </a:solidFill>
+                      <a:prstDash val="solid"/>
+                      <a:round/>
+                      <a:headEnd type="none" w="med" len="med"/>
+                      <a:tailEnd type="none" w="med" len="med"/>
+                    </a:lnR>
+                    <a:lnT w="6350" cap="flat" cmpd="sng" algn="ctr">
+                      <a:solidFill>
+                        <a:srgbClr val="D6CFC4"/>
+                      </a:solidFill>
+                      <a:prstDash val="solid"/>
+                      <a:round/>
+                      <a:headEnd type="none" w="med" len="med"/>
+                      <a:tailEnd type="none" w="med" len="med"/>
+                    </a:lnT>
+                    <a:lnB w="6350" cap="flat" cmpd="sng" algn="ctr">
+                      <a:solidFill>
+                        <a:srgbClr val="D6CFC4"/>
+                      </a:solidFill>
+                      <a:prstDash val="solid"/>
+                      <a:round/>
+                      <a:headEnd type="none" w="med" len="med"/>
+                      <a:tailEnd type="none" w="med" len="med"/>
+                    </a:lnB>
+                    <a:solidFill>
+                      <a:srgbClr val="FFF9D9"/>
+                    </a:solidFill>
+                  </a:tcPr>
+                </a:tc>
+                <a:tc>
+                  <a:txBody>
+                    <a:bodyPr/>
+                    <a:lstStyle/>
+                    <a:p>
+                      <a:pPr algn="ctr" indent="0" marL="0">
+                        <a:buNone/>
+                      </a:pPr>
+                      <a:r>
+                        <a:rPr lang="en-US" sz="1200" dirty="0">
+                          <a:solidFill>
+                            <a:srgbClr val="1A7A6E"/>
+                          </a:solidFill>
+                          <a:latin typeface="Calibri" pitchFamily="34" charset="0"/>
+                          <a:ea typeface="Calibri" pitchFamily="34" charset="-122"/>
+                          <a:cs typeface="Calibri" pitchFamily="34" charset="-120"/>
+                        </a:rPr>
+                        <a:t>↓</a:t>
+                      </a:r>
+                      <a:endParaRPr lang="en-US" sz="1200" dirty="0">
+                        <a:latin typeface="Calibri" charset="0"/>
+                        <a:ea typeface="Calibri" charset="0"/>
+                        <a:cs typeface="Calibri" charset="0"/>
+                      </a:endParaRPr>
+                    </a:p>
+                  </a:txBody>
+                  <a:tcPr marL="91440" marR="91440" marT="45720" marB="45720" anchor="ctr">
+                    <a:lnL w="6350" cap="flat" cmpd="sng" algn="ctr">
+                      <a:solidFill>
+                        <a:srgbClr val="D6CFC4"/>
+                      </a:solidFill>
+                      <a:prstDash val="solid"/>
+                      <a:round/>
+                      <a:headEnd type="none" w="med" len="med"/>
+                      <a:tailEnd type="none" w="med" len="med"/>
+                    </a:lnL>
+                    <a:lnR w="6350" cap="flat" cmpd="sng" algn="ctr">
+                      <a:solidFill>
+                        <a:srgbClr val="D6CFC4"/>
+                      </a:solidFill>
+                      <a:prstDash val="solid"/>
+                      <a:round/>
+                      <a:headEnd type="none" w="med" len="med"/>
+                      <a:tailEnd type="none" w="med" len="med"/>
+                    </a:lnR>
+                    <a:lnT w="6350" cap="flat" cmpd="sng" algn="ctr">
+                      <a:solidFill>
+                        <a:srgbClr val="D6CFC4"/>
+                      </a:solidFill>
+                      <a:prstDash val="solid"/>
+                      <a:round/>
+                      <a:headEnd type="none" w="med" len="med"/>
+                      <a:tailEnd type="none" w="med" len="med"/>
+                    </a:lnT>
+                    <a:lnB w="6350" cap="flat" cmpd="sng" algn="ctr">
+                      <a:solidFill>
+                        <a:srgbClr val="D6CFC4"/>
+                      </a:solidFill>
+                      <a:prstDash val="solid"/>
+                      <a:round/>
+                      <a:headEnd type="none" w="med" len="med"/>
+                      <a:tailEnd type="none" w="med" len="med"/>
+                    </a:lnB>
+                    <a:solidFill>
+                      <a:srgbClr val="FFF9D9"/>
+                    </a:solidFill>
+                  </a:tcPr>
+                </a:tc>
+              </a:tr>
+              <a:tr h="384048">
+                <a:tc>
+                  <a:txBody>
+                    <a:bodyPr/>
+                    <a:lstStyle/>
+                    <a:p>
+                      <a:pPr algn="l" indent="0" marL="0">
+                        <a:buNone/>
+                      </a:pPr>
+                      <a:r>
+                        <a:rPr lang="en-US" sz="1200" b="1" dirty="0">
+                          <a:solidFill>
+                            <a:srgbClr val="2D2A26"/>
+                          </a:solidFill>
+                          <a:latin typeface="Century Gothic" pitchFamily="34" charset="0"/>
+                          <a:ea typeface="Century Gothic" pitchFamily="34" charset="-122"/>
+                          <a:cs typeface="Century Gothic" pitchFamily="34" charset="-120"/>
+                        </a:rPr>
+                        <a:t>Tanzania</a:t>
+                      </a:r>
+                      <a:endParaRPr lang="en-US" sz="1200" dirty="0">
+                        <a:latin typeface="Century Gothic" charset="0"/>
+                        <a:ea typeface="Century Gothic" charset="0"/>
+                        <a:cs typeface="Century Gothic" charset="0"/>
+                      </a:endParaRPr>
+                    </a:p>
+                  </a:txBody>
+                  <a:tcPr marL="91440" marR="91440" marT="45720" marB="45720" anchor="ctr">
+                    <a:lnL w="6350" cap="flat" cmpd="sng" algn="ctr">
+                      <a:solidFill>
+                        <a:srgbClr val="D6CFC4"/>
+                      </a:solidFill>
+                      <a:prstDash val="solid"/>
+                      <a:round/>
+                      <a:headEnd type="none" w="med" len="med"/>
+                      <a:tailEnd type="none" w="med" len="med"/>
+                    </a:lnL>
+                    <a:lnR w="6350" cap="flat" cmpd="sng" algn="ctr">
+                      <a:solidFill>
+                        <a:srgbClr val="D6CFC4"/>
+                      </a:solidFill>
+                      <a:prstDash val="solid"/>
+                      <a:round/>
+                      <a:headEnd type="none" w="med" len="med"/>
+                      <a:tailEnd type="none" w="med" len="med"/>
+                    </a:lnR>
+                    <a:lnT w="6350" cap="flat" cmpd="sng" algn="ctr">
+                      <a:solidFill>
+                        <a:srgbClr val="D6CFC4"/>
+                      </a:solidFill>
+                      <a:prstDash val="solid"/>
+                      <a:round/>
+                      <a:headEnd type="none" w="med" len="med"/>
+                      <a:tailEnd type="none" w="med" len="med"/>
+                    </a:lnT>
+                    <a:lnB w="6350" cap="flat" cmpd="sng" algn="ctr">
+                      <a:solidFill>
+                        <a:srgbClr val="D6CFC4"/>
+                      </a:solidFill>
+                      <a:prstDash val="solid"/>
+                      <a:round/>
+                      <a:headEnd type="none" w="med" len="med"/>
+                      <a:tailEnd type="none" w="med" len="med"/>
+                    </a:lnB>
+                    <a:solidFill>
                       <a:srgbClr val="FFFFFF"/>
                     </a:solidFill>
                   </a:tcPr>
@@ -22473,7 +22405,75 @@
                           <a:ea typeface="Calibri" pitchFamily="34" charset="-122"/>
                           <a:cs typeface="Calibri" pitchFamily="34" charset="-120"/>
                         </a:rPr>
-                        <a:t>6.0%</a:t>
+                        <a:t>7.9%</a:t>
+                      </a:r>
+                      <a:endParaRPr lang="en-US" sz="1200" dirty="0">
+                        <a:latin typeface="Calibri" charset="0"/>
+                        <a:ea typeface="Calibri" charset="0"/>
+                        <a:cs typeface="Calibri" charset="0"/>
+                      </a:endParaRPr>
+                    </a:p>
+                  </a:txBody>
+                  <a:tcPr marL="91440" marR="91440" marT="45720" marB="45720" anchor="ctr">
+                    <a:lnL w="6350" cap="flat" cmpd="sng" algn="ctr">
+                      <a:solidFill>
+                        <a:srgbClr val="D6CFC4"/>
+                      </a:solidFill>
+                      <a:prstDash val="solid"/>
+                      <a:round/>
+                      <a:headEnd type="none" w="med" len="med"/>
+                      <a:tailEnd type="none" w="med" len="med"/>
+                    </a:lnL>
+                    <a:lnR w="6350" cap="flat" cmpd="sng" algn="ctr">
+                      <a:solidFill>
+                        <a:srgbClr val="D6CFC4"/>
+                      </a:solidFill>
+                      <a:prstDash val="solid"/>
+                      <a:round/>
+                      <a:headEnd type="none" w="med" len="med"/>
+                      <a:tailEnd type="none" w="med" len="med"/>
+                    </a:lnR>
+                    <a:lnT w="6350" cap="flat" cmpd="sng" algn="ctr">
+                      <a:solidFill>
+                        <a:srgbClr val="D6CFC4"/>
+                      </a:solidFill>
+                      <a:prstDash val="solid"/>
+                      <a:round/>
+                      <a:headEnd type="none" w="med" len="med"/>
+                      <a:tailEnd type="none" w="med" len="med"/>
+                    </a:lnT>
+                    <a:lnB w="6350" cap="flat" cmpd="sng" algn="ctr">
+                      <a:solidFill>
+                        <a:srgbClr val="D6CFC4"/>
+                      </a:solidFill>
+                      <a:prstDash val="solid"/>
+                      <a:round/>
+                      <a:headEnd type="none" w="med" len="med"/>
+                      <a:tailEnd type="none" w="med" len="med"/>
+                    </a:lnB>
+                    <a:solidFill>
+                      <a:srgbClr val="FFFFFF"/>
+                    </a:solidFill>
+                  </a:tcPr>
+                </a:tc>
+                <a:tc>
+                  <a:txBody>
+                    <a:bodyPr/>
+                    <a:lstStyle/>
+                    <a:p>
+                      <a:pPr algn="ctr" indent="0" marL="0">
+                        <a:buNone/>
+                      </a:pPr>
+                      <a:r>
+                        <a:rPr lang="en-US" sz="1200" dirty="0">
+                          <a:solidFill>
+                            <a:srgbClr val="2D2A26"/>
+                          </a:solidFill>
+                          <a:latin typeface="Calibri" pitchFamily="34" charset="0"/>
+                          <a:ea typeface="Calibri" pitchFamily="34" charset="-122"/>
+                          <a:cs typeface="Calibri" pitchFamily="34" charset="-120"/>
+                        </a:rPr>
+                        <a:t>6.4%</a:t>
                       </a:r>
                       <a:endParaRPr lang="en-US" sz="1200" dirty="0">
                         <a:latin typeface="Calibri" charset="0"/>
@@ -22611,7 +22611,7 @@
                           <a:ea typeface="Century Gothic" pitchFamily="34" charset="-122"/>
                           <a:cs typeface="Century Gothic" pitchFamily="34" charset="-120"/>
                         </a:rPr>
-                        <a:t>Tanzania</a:t>
+                        <a:t>Kenya</a:t>
                       </a:r>
                       <a:endParaRPr lang="en-US" sz="1200" dirty="0">
                         <a:latin typeface="Century Gothic" charset="0"/>
@@ -22679,7 +22679,7 @@
                           <a:ea typeface="Calibri" pitchFamily="34" charset="-122"/>
                           <a:cs typeface="Calibri" pitchFamily="34" charset="-120"/>
                         </a:rPr>
-                        <a:t>7.9%</a:t>
+                        <a:t>8.2%</a:t>
                       </a:r>
                       <a:endParaRPr lang="en-US" sz="1200" dirty="0">
                         <a:latin typeface="Calibri" charset="0"/>
@@ -22747,7 +22747,7 @@
                           <a:ea typeface="Calibri" pitchFamily="34" charset="-122"/>
                           <a:cs typeface="Calibri" pitchFamily="34" charset="-120"/>
                         </a:rPr>
-                        <a:t>6.4%</a:t>
+                        <a:t>7.7%</a:t>
                       </a:r>
                       <a:endParaRPr lang="en-US" sz="1200" dirty="0">
                         <a:latin typeface="Calibri" charset="0"/>
@@ -22885,7 +22885,7 @@
                           <a:ea typeface="Century Gothic" pitchFamily="34" charset="-122"/>
                           <a:cs typeface="Century Gothic" pitchFamily="34" charset="-120"/>
                         </a:rPr>
-                        <a:t>Kenya</a:t>
+                        <a:t>Uganda</a:t>
                       </a:r>
                       <a:endParaRPr lang="en-US" sz="1200" dirty="0">
                         <a:latin typeface="Century Gothic" charset="0"/>
@@ -22953,7 +22953,7 @@
                           <a:ea typeface="Calibri" pitchFamily="34" charset="-122"/>
                           <a:cs typeface="Calibri" pitchFamily="34" charset="-120"/>
                         </a:rPr>
-                        <a:t>8.2%</a:t>
+                        <a:t>15.4%</a:t>
                       </a:r>
                       <a:endParaRPr lang="en-US" sz="1200" dirty="0">
                         <a:latin typeface="Calibri" charset="0"/>
@@ -23021,7 +23021,7 @@
                           <a:ea typeface="Calibri" pitchFamily="34" charset="-122"/>
                           <a:cs typeface="Calibri" pitchFamily="34" charset="-120"/>
                         </a:rPr>
-                        <a:t>7.7%</a:t>
+                        <a:t>13.3%</a:t>
                       </a:r>
                       <a:endParaRPr lang="en-US" sz="1200" dirty="0">
                         <a:latin typeface="Calibri" charset="0"/>
@@ -23227,7 +23227,7 @@
                           <a:ea typeface="Calibri" pitchFamily="34" charset="-122"/>
                           <a:cs typeface="Calibri" pitchFamily="34" charset="-120"/>
                         </a:rPr>
-                        <a:t>7.3%</a:t>
+                        <a:t>8.2%</a:t>
                       </a:r>
                       <a:endParaRPr lang="en-US" sz="1200" dirty="0">
                         <a:latin typeface="Calibri" charset="0"/>
@@ -23295,7 +23295,7 @@
                           <a:ea typeface="Calibri" pitchFamily="34" charset="-122"/>
                           <a:cs typeface="Calibri" pitchFamily="34" charset="-120"/>
                         </a:rPr>
-                        <a:t>6.4%</a:t>
+                        <a:t>7.1%</a:t>
                       </a:r>
                       <a:endParaRPr lang="en-US" sz="1200" dirty="0">
                         <a:latin typeface="Calibri" charset="0"/>

</xml_diff>